<commit_message>
Finalize public deck and harden agent guardrails
</commit_message>
<xml_diff>
--- a/docs/application/voice-agent-summary-deck.pptx
+++ b/docs/application/voice-agent-summary-deck.pptx
@@ -2,22 +2,20 @@
 <file path=ppt/presentation.xml><?xml version="1.0" encoding="utf-8"?>
 <p:presentation xmlns:p="http://schemas.openxmlformats.org/presentationml/2006/main">
   <p:sldMasterIdLst>
-    <p:sldMasterId xmlns:r="http://schemas.openxmlformats.org/officeDocument/2006/relationships" id="2147483648" r:id="Rf5df214d6a274498"/>
+    <p:sldMasterId xmlns:r="http://schemas.openxmlformats.org/officeDocument/2006/relationships" id="2147483648" r:id="R6141321a0b2a4aa2"/>
   </p:sldMasterIdLst>
   <p:notesMasterIdLst>
-    <p:notesMasterId xmlns:r="http://schemas.openxmlformats.org/officeDocument/2006/relationships" r:id="R7b2239e028884592"/>
+    <p:notesMasterId xmlns:r="http://schemas.openxmlformats.org/officeDocument/2006/relationships" r:id="Rd85f4e626f404e1e"/>
   </p:notesMasterIdLst>
   <p:sldIdLst>
-    <p:sldId xmlns:r="http://schemas.openxmlformats.org/officeDocument/2006/relationships" id="256" r:id="R2ef56946ce6c43b9"/>
-    <p:sldId xmlns:r="http://schemas.openxmlformats.org/officeDocument/2006/relationships" id="257" r:id="R4104cc7876a448bd"/>
-    <p:sldId xmlns:r="http://schemas.openxmlformats.org/officeDocument/2006/relationships" id="258" r:id="R7c87d71fd0cb4c13"/>
-    <p:sldId xmlns:r="http://schemas.openxmlformats.org/officeDocument/2006/relationships" id="259" r:id="R3642dd9124c84beb"/>
-    <p:sldId xmlns:r="http://schemas.openxmlformats.org/officeDocument/2006/relationships" id="260" r:id="Rd163d0e057a3432b"/>
-    <p:sldId xmlns:r="http://schemas.openxmlformats.org/officeDocument/2006/relationships" id="261" r:id="R5e5c0af6ffa94f0d"/>
-    <p:sldId xmlns:r="http://schemas.openxmlformats.org/officeDocument/2006/relationships" id="262" r:id="R339dffcbea7547d5"/>
-    <p:sldId xmlns:r="http://schemas.openxmlformats.org/officeDocument/2006/relationships" id="263" r:id="R6ec29d4dcda44e62"/>
-    <p:sldId xmlns:r="http://schemas.openxmlformats.org/officeDocument/2006/relationships" id="264" r:id="R228c4267375f4fbc"/>
-    <p:sldId xmlns:r="http://schemas.openxmlformats.org/officeDocument/2006/relationships" id="265" r:id="R3a5b2c16da684dc4"/>
+    <p:sldId xmlns:r="http://schemas.openxmlformats.org/officeDocument/2006/relationships" id="256" r:id="R9f92796f55d0424b"/>
+    <p:sldId xmlns:r="http://schemas.openxmlformats.org/officeDocument/2006/relationships" id="257" r:id="Reaa9c29aea71493f"/>
+    <p:sldId xmlns:r="http://schemas.openxmlformats.org/officeDocument/2006/relationships" id="258" r:id="Rc583b32841bb4015"/>
+    <p:sldId xmlns:r="http://schemas.openxmlformats.org/officeDocument/2006/relationships" id="259" r:id="Rd4241c624cd24abf"/>
+    <p:sldId xmlns:r="http://schemas.openxmlformats.org/officeDocument/2006/relationships" id="260" r:id="Rdaf7acc8a46d4e6e"/>
+    <p:sldId xmlns:r="http://schemas.openxmlformats.org/officeDocument/2006/relationships" id="261" r:id="Rb970cdfc0f7c48d4"/>
+    <p:sldId xmlns:r="http://schemas.openxmlformats.org/officeDocument/2006/relationships" id="262" r:id="Rbb94438f50f94b2a"/>
+    <p:sldId xmlns:r="http://schemas.openxmlformats.org/officeDocument/2006/relationships" id="263" r:id="Rafb91d132e414a07"/>
   </p:sldIdLst>
   <p:sldSz cx="12192000" cy="6858000"/>
   <p:notesSz cx="6858000" cy="9144000"/>
@@ -449,101 +447,7 @@
         <p:txBody>
           <a:bodyPr xmlns:a="http://schemas.openxmlformats.org/drawingml/2006/main"/>
           <a:lstStyle xmlns:a="http://schemas.openxmlformats.org/drawingml/2006/main"/>
-          <a:p xmlns:a="http://schemas.openxmlformats.org/drawingml/2006/main">
-            <a:r>
-              <a:t>Open by separating this repo from a generic chatbot demo.</a:t>
-            </a:r>
-          </a:p>
-          <a:p xmlns:a="http://schemas.openxmlformats.org/drawingml/2006/main">
-            <a:r>
-              <a:t>Emphasise that the project is designed to be read, run, interrupted, and evaluated.</a:t>
-            </a:r>
-          </a:p>
-          <a:p xmlns:a="http://schemas.openxmlformats.org/drawingml/2006/main">
-            <a:r>
-              <a:t>[Sources] README.md lines 1-13; docs/design/repo-hero-banner.png.</a:t>
-            </a:r>
-          </a:p>
-        </p:txBody>
-      </p:sp>
-      <p:sp>
-        <p:nvSpPr>
-          <p:cNvPr id="4" name="Slide Number Placeholder 3"/>
-          <p:cNvSpPr>
-            <a:spLocks xmlns:a="http://schemas.openxmlformats.org/drawingml/2006/main" noGrp="1"/>
-          </p:cNvSpPr>
-          <p:nvPr>
-            <p:ph type="sldNum" idx="5"/>
-          </p:nvPr>
-        </p:nvSpPr>
-        <p:spPr/>
-        <p:txBody>
-          <a:bodyPr xmlns:a="http://schemas.openxmlformats.org/drawingml/2006/main"/>
-          <a:lstStyle xmlns:a="http://schemas.openxmlformats.org/drawingml/2006/main"/>
           <a:p xmlns:a="http://schemas.openxmlformats.org/drawingml/2006/main"/>
-        </p:txBody>
-      </p:sp>
-    </p:spTree>
-  </p:cSld>
-  <p:clrMapOvr>
-    <a:masterClrMapping xmlns:a="http://schemas.openxmlformats.org/drawingml/2006/main"/>
-  </p:clrMapOvr>
-</p:notes>
-</file>
-
-<file path=ppt/notesSlides/notesSlide10.xml><?xml version="1.0" encoding="utf-8"?>
-<p:notes xmlns:p="http://schemas.openxmlformats.org/presentationml/2006/main">
-  <p:cSld>
-    <p:spTree>
-      <p:nvGrpSpPr>
-        <p:cNvPr id="1" name=""/>
-        <p:cNvGrpSpPr/>
-        <p:nvPr/>
-      </p:nvGrpSpPr>
-      <p:grpSpPr>
-        <a:xfrm xmlns:a="http://schemas.openxmlformats.org/drawingml/2006/main"/>
-      </p:grpSpPr>
-      <p:sp>
-        <p:nvSpPr>
-          <p:cNvPr id="2" name="Slide Image Placeholder 1"/>
-          <p:cNvSpPr>
-            <a:spLocks xmlns:a="http://schemas.openxmlformats.org/drawingml/2006/main" noGrp="1"/>
-          </p:cNvSpPr>
-          <p:nvPr>
-            <p:ph type="sldImg" idx="0"/>
-          </p:nvPr>
-        </p:nvSpPr>
-        <p:spPr/>
-      </p:sp>
-      <p:sp>
-        <p:nvSpPr>
-          <p:cNvPr id="3" name="Notes Placeholder 2"/>
-          <p:cNvSpPr>
-            <a:spLocks xmlns:a="http://schemas.openxmlformats.org/drawingml/2006/main" noGrp="1"/>
-          </p:cNvSpPr>
-          <p:nvPr>
-            <p:ph type="body" idx="1"/>
-          </p:nvPr>
-        </p:nvSpPr>
-        <p:spPr/>
-        <p:txBody>
-          <a:bodyPr xmlns:a="http://schemas.openxmlformats.org/drawingml/2006/main"/>
-          <a:lstStyle xmlns:a="http://schemas.openxmlformats.org/drawingml/2006/main"/>
-          <a:p xmlns:a="http://schemas.openxmlformats.org/drawingml/2006/main">
-            <a:r>
-              <a:t>Use this as the close before the live demo. It tells the reviewer how to read the repository.</a:t>
-            </a:r>
-          </a:p>
-          <a:p xmlns:a="http://schemas.openxmlformats.org/drawingml/2006/main">
-            <a:r>
-              <a:t>Mention Vercel carefully: a static showcase or cloud-provider version is reasonable; the full local-model stack remains best as local/browser.</a:t>
-            </a:r>
-          </a:p>
-          <a:p xmlns:a="http://schemas.openxmlformats.org/drawingml/2006/main">
-            <a:r>
-              <a:t>[Sources] README.md lines 519-546; project test and bench runs performed locally.</a:t>
-            </a:r>
-          </a:p>
         </p:txBody>
       </p:sp>
       <p:sp>
@@ -609,21 +513,7 @@
         <p:txBody>
           <a:bodyPr xmlns:a="http://schemas.openxmlformats.org/drawingml/2006/main"/>
           <a:lstStyle xmlns:a="http://schemas.openxmlformats.org/drawingml/2006/main"/>
-          <a:p xmlns:a="http://schemas.openxmlformats.org/drawingml/2006/main">
-            <a:r>
-              <a:t>This slide frames the engineering problem before showing the architecture.</a:t>
-            </a:r>
-          </a:p>
-          <a:p xmlns:a="http://schemas.openxmlformats.org/drawingml/2006/main">
-            <a:r>
-              <a:t>Talk about real calls: pauses, interruptions, echo, and state consistency.</a:t>
-            </a:r>
-          </a:p>
-          <a:p xmlns:a="http://schemas.openxmlformats.org/drawingml/2006/main">
-            <a:r>
-              <a:t>[Sources] docs/architecture.md lines 7-10, 16-18, 50-63, 64-80.</a:t>
-            </a:r>
-          </a:p>
+          <a:p xmlns:a="http://schemas.openxmlformats.org/drawingml/2006/main"/>
         </p:txBody>
       </p:sp>
       <p:sp>
@@ -689,21 +579,7 @@
         <p:txBody>
           <a:bodyPr xmlns:a="http://schemas.openxmlformats.org/drawingml/2006/main"/>
           <a:lstStyle xmlns:a="http://schemas.openxmlformats.org/drawingml/2006/main"/>
-          <a:p xmlns:a="http://schemas.openxmlformats.org/drawingml/2006/main">
-            <a:r>
-              <a:t>Walk left to right: browser or future telephony transport, RxPump, frame channel, VAD, ASR, LangGraph, tools, TTS, playback.</a:t>
-            </a:r>
-          </a:p>
-          <a:p xmlns:a="http://schemas.openxmlformats.org/drawingml/2006/main">
-            <a:r>
-              <a:t>Name the architectural boundary: framework reasoning outside the 20ms loop.</a:t>
-            </a:r>
-          </a:p>
-          <a:p xmlns:a="http://schemas.openxmlformats.org/drawingml/2006/main">
-            <a:r>
-              <a:t>[Sources] README.md lines 22-48; src/voice_agent/rx.py lines 112-140; src/voice_agent/agent/graph.py lines 6-12.</a:t>
-            </a:r>
-          </a:p>
+          <a:p xmlns:a="http://schemas.openxmlformats.org/drawingml/2006/main"/>
         </p:txBody>
       </p:sp>
       <p:sp>
@@ -769,21 +645,7 @@
         <p:txBody>
           <a:bodyPr xmlns:a="http://schemas.openxmlformats.org/drawingml/2006/main"/>
           <a:lstStyle xmlns:a="http://schemas.openxmlformats.org/drawingml/2006/main"/>
-          <a:p xmlns:a="http://schemas.openxmlformats.org/drawingml/2006/main">
-            <a:r>
-              <a:t>Explain why full generated text cannot be blindly committed after an interruption.</a:t>
-            </a:r>
-          </a:p>
-          <a:p xmlns:a="http://schemas.openxmlformats.org/drawingml/2006/main">
-            <a:r>
-              <a:t>This is the strongest technical differentiator: state remains caller-truthful after cancellation.</a:t>
-            </a:r>
-          </a:p>
-          <a:p xmlns:a="http://schemas.openxmlformats.org/drawingml/2006/main">
-            <a:r>
-              <a:t>[Sources] README.md lines 64-70 and 359-368; src/voice_agent/pipeline.py lines 325-365; src/voice_agent/session.py lines 30-80.</a:t>
-            </a:r>
-          </a:p>
+          <a:p xmlns:a="http://schemas.openxmlformats.org/drawingml/2006/main"/>
         </p:txBody>
       </p:sp>
       <p:sp>
@@ -849,21 +711,7 @@
         <p:txBody>
           <a:bodyPr xmlns:a="http://schemas.openxmlformats.org/drawingml/2006/main"/>
           <a:lstStyle xmlns:a="http://schemas.openxmlformats.org/drawingml/2006/main"/>
-          <a:p xmlns:a="http://schemas.openxmlformats.org/drawingml/2006/main">
-            <a:r>
-              <a:t>Use this slide to connect the project to Acto: ERP, CRM, behaviour, revenue signals, and action orchestration.</a:t>
-            </a:r>
-          </a:p>
-          <a:p xmlns:a="http://schemas.openxmlformats.org/drawingml/2006/main">
-            <a:r>
-              <a:t>Emphasise that guardrails are implemented in tools rather than delegated to prompting.</a:t>
-            </a:r>
-          </a:p>
-          <a:p xmlns:a="http://schemas.openxmlformats.org/drawingml/2006/main">
-            <a:r>
-              <a:t>[Sources] README.md lines 78-108; src/voice_agent/agent/tools/sales.py lines 1-20 and 60-65.</a:t>
-            </a:r>
-          </a:p>
+          <a:p xmlns:a="http://schemas.openxmlformats.org/drawingml/2006/main"/>
         </p:txBody>
       </p:sp>
       <p:sp>
@@ -929,21 +777,7 @@
         <p:txBody>
           <a:bodyPr xmlns:a="http://schemas.openxmlformats.org/drawingml/2006/main"/>
           <a:lstStyle xmlns:a="http://schemas.openxmlformats.org/drawingml/2006/main"/>
-          <a:p xmlns:a="http://schemas.openxmlformats.org/drawingml/2006/main">
-            <a:r>
-              <a:t>Explain why this is BM25/FTS5 rather than embeddings: small corpus, deterministic, fast, and enough to test the voice-agent behaviour.</a:t>
-            </a:r>
-          </a:p>
-          <a:p xmlns:a="http://schemas.openxmlformats.org/drawingml/2006/main">
-            <a:r>
-              <a:t>Mention the bench command reproduced these numbers locally.</a:t>
-            </a:r>
-          </a:p>
-          <a:p xmlns:a="http://schemas.openxmlformats.org/drawingml/2006/main">
-            <a:r>
-              <a:t>[Sources] README.md lines 110-165; bench.retrieval local run; docs/architecture.md lines 150-177.</a:t>
-            </a:r>
-          </a:p>
+          <a:p xmlns:a="http://schemas.openxmlformats.org/drawingml/2006/main"/>
         </p:txBody>
       </p:sp>
       <p:sp>
@@ -1009,21 +843,7 @@
         <p:txBody>
           <a:bodyPr xmlns:a="http://schemas.openxmlformats.org/drawingml/2006/main"/>
           <a:lstStyle xmlns:a="http://schemas.openxmlformats.org/drawingml/2006/main"/>
-          <a:p xmlns:a="http://schemas.openxmlformats.org/drawingml/2006/main">
-            <a:r>
-              <a:t>Use this slide to show simulation-based testing, which Acto explicitly asks for.</a:t>
-            </a:r>
-          </a:p>
-          <a:p xmlns:a="http://schemas.openxmlformats.org/drawingml/2006/main">
-            <a:r>
-              <a:t>Be candid: 26/33 is not perfect, and that is part of the point. The system reports residual failures rather than hiding them.</a:t>
-            </a:r>
-          </a:p>
-          <a:p xmlns:a="http://schemas.openxmlformats.org/drawingml/2006/main">
-            <a:r>
-              <a:t>[Sources] evals/harness.py lines 1-15 and 102-166; evals/scenarios/*.yaml; src/voice_agent/server/static/eval-summary.json.</a:t>
-            </a:r>
-          </a:p>
+          <a:p xmlns:a="http://schemas.openxmlformats.org/drawingml/2006/main"/>
         </p:txBody>
       </p:sp>
       <p:sp>
@@ -1089,101 +909,7 @@
         <p:txBody>
           <a:bodyPr xmlns:a="http://schemas.openxmlformats.org/drawingml/2006/main"/>
           <a:lstStyle xmlns:a="http://schemas.openxmlformats.org/drawingml/2006/main"/>
-          <a:p xmlns:a="http://schemas.openxmlformats.org/drawingml/2006/main">
-            <a:r>
-              <a:t>This is the humility slide. It shows mature engineering judgement and gives you several interview stories.</a:t>
-            </a:r>
-          </a:p>
-          <a:p xmlns:a="http://schemas.openxmlformats.org/drawingml/2006/main">
-            <a:r>
-              <a:t>Use the endpointer story as the best trade-off example.</a:t>
-            </a:r>
-          </a:p>
-          <a:p xmlns:a="http://schemas.openxmlformats.org/drawingml/2006/main">
-            <a:r>
-              <a:t>[Sources] README.md lines 325-384 and 438-479; docs/architecture.md lines 209-238.</a:t>
-            </a:r>
-          </a:p>
-        </p:txBody>
-      </p:sp>
-      <p:sp>
-        <p:nvSpPr>
-          <p:cNvPr id="4" name="Slide Number Placeholder 3"/>
-          <p:cNvSpPr>
-            <a:spLocks xmlns:a="http://schemas.openxmlformats.org/drawingml/2006/main" noGrp="1"/>
-          </p:cNvSpPr>
-          <p:nvPr>
-            <p:ph type="sldNum" idx="5"/>
-          </p:nvPr>
-        </p:nvSpPr>
-        <p:spPr/>
-        <p:txBody>
-          <a:bodyPr xmlns:a="http://schemas.openxmlformats.org/drawingml/2006/main"/>
-          <a:lstStyle xmlns:a="http://schemas.openxmlformats.org/drawingml/2006/main"/>
           <a:p xmlns:a="http://schemas.openxmlformats.org/drawingml/2006/main"/>
-        </p:txBody>
-      </p:sp>
-    </p:spTree>
-  </p:cSld>
-  <p:clrMapOvr>
-    <a:masterClrMapping xmlns:a="http://schemas.openxmlformats.org/drawingml/2006/main"/>
-  </p:clrMapOvr>
-</p:notes>
-</file>
-
-<file path=ppt/notesSlides/notesSlide9.xml><?xml version="1.0" encoding="utf-8"?>
-<p:notes xmlns:p="http://schemas.openxmlformats.org/presentationml/2006/main">
-  <p:cSld>
-    <p:spTree>
-      <p:nvGrpSpPr>
-        <p:cNvPr id="1" name=""/>
-        <p:cNvGrpSpPr/>
-        <p:nvPr/>
-      </p:nvGrpSpPr>
-      <p:grpSpPr>
-        <a:xfrm xmlns:a="http://schemas.openxmlformats.org/drawingml/2006/main"/>
-      </p:grpSpPr>
-      <p:sp>
-        <p:nvSpPr>
-          <p:cNvPr id="2" name="Slide Image Placeholder 1"/>
-          <p:cNvSpPr>
-            <a:spLocks xmlns:a="http://schemas.openxmlformats.org/drawingml/2006/main" noGrp="1"/>
-          </p:cNvSpPr>
-          <p:nvPr>
-            <p:ph type="sldImg" idx="0"/>
-          </p:nvPr>
-        </p:nvSpPr>
-        <p:spPr/>
-      </p:sp>
-      <p:sp>
-        <p:nvSpPr>
-          <p:cNvPr id="3" name="Notes Placeholder 2"/>
-          <p:cNvSpPr>
-            <a:spLocks xmlns:a="http://schemas.openxmlformats.org/drawingml/2006/main" noGrp="1"/>
-          </p:cNvSpPr>
-          <p:nvPr>
-            <p:ph type="body" idx="1"/>
-          </p:nvPr>
-        </p:nvSpPr>
-        <p:spPr/>
-        <p:txBody>
-          <a:bodyPr xmlns:a="http://schemas.openxmlformats.org/drawingml/2006/main"/>
-          <a:lstStyle xmlns:a="http://schemas.openxmlformats.org/drawingml/2006/main"/>
-          <a:p xmlns:a="http://schemas.openxmlformats.org/drawingml/2006/main">
-            <a:r>
-              <a:t>This is your recording plan. Keep the intro tight, then switch to the browser demo.</a:t>
-            </a:r>
-          </a:p>
-          <a:p xmlns:a="http://schemas.openxmlformats.org/drawingml/2006/main">
-            <a:r>
-              <a:t>Do not try to show every feature live. Prove the behaviours that Acto cares about most.</a:t>
-            </a:r>
-          </a:p>
-          <a:p xmlns:a="http://schemas.openxmlformats.org/drawingml/2006/main">
-            <a:r>
-              <a:t>[Sources] README.md quick start lines 481-513; src/voice_agent/server/static/demo.html.</a:t>
-            </a:r>
-          </a:p>
         </p:txBody>
       </p:sp>
       <p:sp>
@@ -1249,7 +975,7 @@
   </p:cSld>
   <p:clrMap bg1="lt1" tx1="dk1" bg2="lt2" tx2="dk2" accent1="accent1" accent2="accent2" accent3="accent3" accent4="accent4" accent5="accent5" accent6="accent6" hlink="hlink" folHlink="folHlink"/>
   <p:sldLayoutIdLst>
-    <p:sldLayoutId xmlns:r="http://schemas.openxmlformats.org/officeDocument/2006/relationships" id="2147483649" r:id="Re8bab5e30231430e"/>
+    <p:sldLayoutId xmlns:r="http://schemas.openxmlformats.org/officeDocument/2006/relationships" id="2147483649" r:id="R08380b6a0d934c1b"/>
   </p:sldLayoutIdLst>
   <p:txStyles>
     <p:titleStyle>
@@ -1797,14 +1523,14 @@
       </p:grpSpPr>
       <p:pic>
         <p:nvPicPr>
-          <p:cNvPr id="5" name=""/>
+          <p:cNvPr id="12" name=""/>
           <p:cNvPicPr>
             <a:picLocks xmlns:a="http://schemas.openxmlformats.org/drawingml/2006/main" noChangeAspect="1"/>
           </p:cNvPicPr>
           <p:nvPr/>
         </p:nvPicPr>
         <p:blipFill>
-          <a:blip xmlns:r="http://schemas.openxmlformats.org/officeDocument/2006/relationships" xmlns:a="http://schemas.openxmlformats.org/drawingml/2006/main" r:embed="R550cb204f8cd464f"/>
+          <a:blip xmlns:r="http://schemas.openxmlformats.org/officeDocument/2006/relationships" xmlns:a="http://schemas.openxmlformats.org/drawingml/2006/main" r:embed="Rbc1fcddd2da04a47"/>
           <a:srcRect xmlns:a="http://schemas.openxmlformats.org/drawingml/2006/main" l="0" t="0" r="0" b="0"/>
           <a:stretch xmlns:a="http://schemas.openxmlformats.org/drawingml/2006/main">
             <a:fillRect l="0" t="0" r="0" b="0"/>
@@ -1855,6 +1581,7 @@
           <a:lstStyle xmlns:a="http://schemas.openxmlformats.org/drawingml/2006/main"/>
           <a:p xmlns:a="http://schemas.openxmlformats.org/drawingml/2006/main">
             <a:pPr algn="l">
+              <a:buNone/>
               <a:defRPr sz="3750" b="1">
                 <a:solidFill>
                   <a:srgbClr val="E6EFEB"/>
@@ -1905,6 +1632,7 @@
           <a:lstStyle xmlns:a="http://schemas.openxmlformats.org/drawingml/2006/main"/>
           <a:p xmlns:a="http://schemas.openxmlformats.org/drawingml/2006/main">
             <a:pPr algn="l">
+              <a:buNone/>
               <a:defRPr sz="1650" b="0">
                 <a:solidFill>
                   <a:srgbClr val="8CA098"/>
@@ -1955,6 +1683,7 @@
           <a:lstStyle xmlns:a="http://schemas.openxmlformats.org/drawingml/2006/main"/>
           <a:p xmlns:a="http://schemas.openxmlformats.org/drawingml/2006/main">
             <a:pPr algn="r">
+              <a:buNone/>
               <a:defRPr sz="1350" b="1">
                 <a:solidFill>
                   <a:srgbClr val="34D399"/>
@@ -1967,7 +1696,277 @@
                   <a:srgbClr val="34D399"/>
                 </a:solidFill>
               </a:rPr>
-              <a:t>Recording deck</a:t>
+              <a:t>Project brief</a:t>
+            </a:r>
+          </a:p>
+        </p:txBody>
+      </p:sp>
+      <p:sp>
+        <p:nvSpPr>
+          <p:cNvPr id="6" name="">
+            <a:extLst xmlns:a="http://schemas.openxmlformats.org/drawingml/2006/main">
+              <a:ext uri="{FF2B5EF4-FFF2-40B4-BE49-F238E27FC236}">
+                <a16:creationId xmlns:a16="http://schemas.microsoft.com/office/drawing/2014/main" id="{FD25F20A-E25D-412C-9072-BA4EEDFC41F8}"/>
+              </a:ext>
+            </a:extLst>
+          </p:cNvPr>
+          <p:cNvSpPr>
+            <a:spLocks xmlns:a="http://schemas.openxmlformats.org/drawingml/2006/main" noGrp="1"/>
+          </p:cNvSpPr>
+          <p:nvPr/>
+        </p:nvSpPr>
+        <p:spPr>
+          <a:xfrm xmlns:a="http://schemas.openxmlformats.org/drawingml/2006/main">
+            <a:off x="2590800" y="1657350"/>
+            <a:ext cx="1676400" cy="447675"/>
+          </a:xfrm>
+          <a:prstGeom xmlns:a="http://schemas.openxmlformats.org/drawingml/2006/main" prst="roundRect">
+            <a:avLst>
+              <a:gd name="adj" fmla="val 17021"/>
+            </a:avLst>
+          </a:prstGeom>
+          <a:solidFill xmlns:a="http://schemas.openxmlformats.org/drawingml/2006/main">
+            <a:srgbClr val="16201D"/>
+          </a:solidFill>
+          <a:ln xmlns:a="http://schemas.openxmlformats.org/drawingml/2006/main" w="9525">
+            <a:solidFill>
+              <a:srgbClr val="26322F"/>
+            </a:solidFill>
+            <a:prstDash val="solid"/>
+          </a:ln>
+        </p:spPr>
+      </p:sp>
+      <p:sp>
+        <p:nvSpPr>
+          <p:cNvPr id="7" name="">
+            <a:extLst xmlns:a="http://schemas.openxmlformats.org/drawingml/2006/main">
+              <a:ext uri="{FF2B5EF4-FFF2-40B4-BE49-F238E27FC236}">
+                <a16:creationId xmlns:a16="http://schemas.microsoft.com/office/drawing/2014/main" id="{917B6744-EF3C-494E-B0DF-D6F73FE21730}"/>
+              </a:ext>
+            </a:extLst>
+          </p:cNvPr>
+          <p:cNvSpPr>
+            <a:spLocks xmlns:a="http://schemas.openxmlformats.org/drawingml/2006/main" noGrp="1"/>
+          </p:cNvSpPr>
+          <p:nvPr/>
+        </p:nvSpPr>
+        <p:spPr>
+          <a:xfrm xmlns:a="http://schemas.openxmlformats.org/drawingml/2006/main">
+            <a:off x="2724150" y="1809750"/>
+            <a:ext cx="1352550" cy="123825"/>
+          </a:xfrm>
+          <a:prstGeom xmlns:a="http://schemas.openxmlformats.org/drawingml/2006/main" prst="rect">
+            <a:avLst/>
+          </a:prstGeom>
+          <a:noFill xmlns:a="http://schemas.openxmlformats.org/drawingml/2006/main"/>
+          <a:ln xmlns:a="http://schemas.openxmlformats.org/drawingml/2006/main" w="0">
+            <a:noFill/>
+            <a:prstDash val="solid"/>
+          </a:ln>
+        </p:spPr>
+        <p:txBody>
+          <a:bodyPr xmlns:a="http://schemas.openxmlformats.org/drawingml/2006/main"/>
+          <a:lstStyle xmlns:a="http://schemas.openxmlformats.org/drawingml/2006/main"/>
+          <a:p xmlns:a="http://schemas.openxmlformats.org/drawingml/2006/main">
+            <a:pPr>
+              <a:defRPr sz="750">
+                <a:solidFill>
+                  <a:srgbClr val="8CA098"/>
+                </a:solidFill>
+              </a:defRPr>
+            </a:pPr>
+            <a:r>
+              <a:rPr sz="750">
+                <a:solidFill>
+                  <a:srgbClr val="8CA098"/>
+                </a:solidFill>
+              </a:rPr>
+              <a:t>Barge-in</a:t>
+            </a:r>
+          </a:p>
+        </p:txBody>
+      </p:sp>
+      <p:sp>
+        <p:nvSpPr>
+          <p:cNvPr id="8" name="">
+            <a:extLst xmlns:a="http://schemas.openxmlformats.org/drawingml/2006/main">
+              <a:ext uri="{FF2B5EF4-FFF2-40B4-BE49-F238E27FC236}">
+                <a16:creationId xmlns:a16="http://schemas.microsoft.com/office/drawing/2014/main" id="{DD015AB7-3BB0-46C3-A7E9-775EB650A04B}"/>
+              </a:ext>
+            </a:extLst>
+          </p:cNvPr>
+          <p:cNvSpPr>
+            <a:spLocks xmlns:a="http://schemas.openxmlformats.org/drawingml/2006/main" noGrp="1"/>
+          </p:cNvSpPr>
+          <p:nvPr/>
+        </p:nvSpPr>
+        <p:spPr>
+          <a:xfrm xmlns:a="http://schemas.openxmlformats.org/drawingml/2006/main">
+            <a:off x="2724150" y="1971675"/>
+            <a:ext cx="1428750" cy="152400"/>
+          </a:xfrm>
+          <a:prstGeom xmlns:a="http://schemas.openxmlformats.org/drawingml/2006/main" prst="rect">
+            <a:avLst/>
+          </a:prstGeom>
+          <a:noFill xmlns:a="http://schemas.openxmlformats.org/drawingml/2006/main"/>
+          <a:ln xmlns:a="http://schemas.openxmlformats.org/drawingml/2006/main" w="0">
+            <a:noFill/>
+            <a:prstDash val="solid"/>
+          </a:ln>
+        </p:spPr>
+        <p:txBody>
+          <a:bodyPr xmlns:a="http://schemas.openxmlformats.org/drawingml/2006/main"/>
+          <a:lstStyle xmlns:a="http://schemas.openxmlformats.org/drawingml/2006/main"/>
+          <a:p xmlns:a="http://schemas.openxmlformats.org/drawingml/2006/main">
+            <a:pPr>
+              <a:defRPr sz="1050">
+                <a:solidFill>
+                  <a:srgbClr val="34D399"/>
+                </a:solidFill>
+              </a:defRPr>
+            </a:pPr>
+            <a:r>
+              <a:rPr sz="1050">
+                <a:solidFill>
+                  <a:srgbClr val="34D399"/>
+                </a:solidFill>
+              </a:rPr>
+              <a:t>p50 328ms</a:t>
+            </a:r>
+          </a:p>
+        </p:txBody>
+      </p:sp>
+      <p:sp>
+        <p:nvSpPr>
+          <p:cNvPr id="9" name="">
+            <a:extLst xmlns:a="http://schemas.openxmlformats.org/drawingml/2006/main">
+              <a:ext uri="{FF2B5EF4-FFF2-40B4-BE49-F238E27FC236}">
+                <a16:creationId xmlns:a16="http://schemas.microsoft.com/office/drawing/2014/main" id="{DD8E5ABE-4DB6-41D6-B890-6EC2414C9E31}"/>
+              </a:ext>
+            </a:extLst>
+          </p:cNvPr>
+          <p:cNvSpPr>
+            <a:spLocks xmlns:a="http://schemas.openxmlformats.org/drawingml/2006/main" noGrp="1"/>
+          </p:cNvSpPr>
+          <p:nvPr/>
+        </p:nvSpPr>
+        <p:spPr>
+          <a:xfrm xmlns:a="http://schemas.openxmlformats.org/drawingml/2006/main">
+            <a:off x="6248400" y="1657350"/>
+            <a:ext cx="1295400" cy="447675"/>
+          </a:xfrm>
+          <a:prstGeom xmlns:a="http://schemas.openxmlformats.org/drawingml/2006/main" prst="roundRect">
+            <a:avLst>
+              <a:gd name="adj" fmla="val 17021"/>
+            </a:avLst>
+          </a:prstGeom>
+          <a:solidFill xmlns:a="http://schemas.openxmlformats.org/drawingml/2006/main">
+            <a:srgbClr val="16201D"/>
+          </a:solidFill>
+          <a:ln xmlns:a="http://schemas.openxmlformats.org/drawingml/2006/main" w="9525">
+            <a:solidFill>
+              <a:srgbClr val="26322F"/>
+            </a:solidFill>
+            <a:prstDash val="solid"/>
+          </a:ln>
+        </p:spPr>
+      </p:sp>
+      <p:sp>
+        <p:nvSpPr>
+          <p:cNvPr id="10" name="">
+            <a:extLst xmlns:a="http://schemas.openxmlformats.org/drawingml/2006/main">
+              <a:ext uri="{FF2B5EF4-FFF2-40B4-BE49-F238E27FC236}">
+                <a16:creationId xmlns:a16="http://schemas.microsoft.com/office/drawing/2014/main" id="{54285200-27D8-49B6-8090-01FCC6BC2F0E}"/>
+              </a:ext>
+            </a:extLst>
+          </p:cNvPr>
+          <p:cNvSpPr>
+            <a:spLocks xmlns:a="http://schemas.openxmlformats.org/drawingml/2006/main" noGrp="1"/>
+          </p:cNvSpPr>
+          <p:nvPr/>
+        </p:nvSpPr>
+        <p:spPr>
+          <a:xfrm xmlns:a="http://schemas.openxmlformats.org/drawingml/2006/main">
+            <a:off x="6381750" y="1809750"/>
+            <a:ext cx="1028700" cy="123825"/>
+          </a:xfrm>
+          <a:prstGeom xmlns:a="http://schemas.openxmlformats.org/drawingml/2006/main" prst="rect">
+            <a:avLst/>
+          </a:prstGeom>
+          <a:noFill xmlns:a="http://schemas.openxmlformats.org/drawingml/2006/main"/>
+          <a:ln xmlns:a="http://schemas.openxmlformats.org/drawingml/2006/main" w="0">
+            <a:noFill/>
+            <a:prstDash val="solid"/>
+          </a:ln>
+        </p:spPr>
+        <p:txBody>
+          <a:bodyPr xmlns:a="http://schemas.openxmlformats.org/drawingml/2006/main"/>
+          <a:lstStyle xmlns:a="http://schemas.openxmlformats.org/drawingml/2006/main"/>
+          <a:p xmlns:a="http://schemas.openxmlformats.org/drawingml/2006/main">
+            <a:pPr>
+              <a:defRPr sz="750">
+                <a:solidFill>
+                  <a:srgbClr val="8CA098"/>
+                </a:solidFill>
+              </a:defRPr>
+            </a:pPr>
+            <a:r>
+              <a:rPr sz="750">
+                <a:solidFill>
+                  <a:srgbClr val="8CA098"/>
+                </a:solidFill>
+              </a:rPr>
+              <a:t>Tests</a:t>
+            </a:r>
+          </a:p>
+        </p:txBody>
+      </p:sp>
+      <p:sp>
+        <p:nvSpPr>
+          <p:cNvPr id="11" name="">
+            <a:extLst xmlns:a="http://schemas.openxmlformats.org/drawingml/2006/main">
+              <a:ext uri="{FF2B5EF4-FFF2-40B4-BE49-F238E27FC236}">
+                <a16:creationId xmlns:a16="http://schemas.microsoft.com/office/drawing/2014/main" id="{620CF5A7-EA43-4866-BD2E-E93573734E74}"/>
+              </a:ext>
+            </a:extLst>
+          </p:cNvPr>
+          <p:cNvSpPr>
+            <a:spLocks xmlns:a="http://schemas.openxmlformats.org/drawingml/2006/main" noGrp="1"/>
+          </p:cNvSpPr>
+          <p:nvPr/>
+        </p:nvSpPr>
+        <p:spPr>
+          <a:xfrm xmlns:a="http://schemas.openxmlformats.org/drawingml/2006/main">
+            <a:off x="6381750" y="1971675"/>
+            <a:ext cx="1104900" cy="152400"/>
+          </a:xfrm>
+          <a:prstGeom xmlns:a="http://schemas.openxmlformats.org/drawingml/2006/main" prst="rect">
+            <a:avLst/>
+          </a:prstGeom>
+          <a:noFill xmlns:a="http://schemas.openxmlformats.org/drawingml/2006/main"/>
+          <a:ln xmlns:a="http://schemas.openxmlformats.org/drawingml/2006/main" w="0">
+            <a:noFill/>
+            <a:prstDash val="solid"/>
+          </a:ln>
+        </p:spPr>
+        <p:txBody>
+          <a:bodyPr xmlns:a="http://schemas.openxmlformats.org/drawingml/2006/main"/>
+          <a:lstStyle xmlns:a="http://schemas.openxmlformats.org/drawingml/2006/main"/>
+          <a:p xmlns:a="http://schemas.openxmlformats.org/drawingml/2006/main">
+            <a:pPr>
+              <a:defRPr sz="1050">
+                <a:solidFill>
+                  <a:srgbClr val="34D399"/>
+                </a:solidFill>
+              </a:defRPr>
+            </a:pPr>
+            <a:r>
+              <a:rPr sz="1050">
+                <a:solidFill>
+                  <a:srgbClr val="34D399"/>
+                </a:solidFill>
+              </a:rPr>
+              <a:t>run suite</a:t>
             </a:r>
           </a:p>
         </p:txBody>
@@ -1976,999 +1975,6 @@
     <p:extLst>
       <p:ext uri="{BB962C8B-B14F-4D97-AF65-F5344CB8AC3E}">
         <p14:creationId xmlns:p14="http://schemas.microsoft.com/office/powerpoint/2010/main" val="782448665"/>
-      </p:ext>
-    </p:extLst>
-  </p:cSld>
-</p:sld>
-</file>
-
-<file path=ppt/slides/slide10.xml><?xml version="1.0" encoding="utf-8"?>
-<p:sld xmlns:p="http://schemas.openxmlformats.org/presentationml/2006/main">
-  <p:cSld>
-    <p:bg>
-      <p:bgPr>
-        <a:solidFill xmlns:a="http://schemas.openxmlformats.org/drawingml/2006/main">
-          <a:srgbClr val="0B0F0E"/>
-        </a:solidFill>
-      </p:bgPr>
-    </p:bg>
-    <p:spTree>
-      <p:nvGrpSpPr>
-        <p:cNvPr id="1" name=""/>
-        <p:cNvGrpSpPr/>
-        <p:nvPr/>
-      </p:nvGrpSpPr>
-      <p:grpSpPr>
-        <a:xfrm xmlns:a="http://schemas.openxmlformats.org/drawingml/2006/main"/>
-      </p:grpSpPr>
-      <p:sp>
-        <p:nvSpPr>
-          <p:cNvPr id="23" name="">
-            <a:extLst xmlns:a="http://schemas.openxmlformats.org/drawingml/2006/main">
-              <a:ext uri="{FF2B5EF4-FFF2-40B4-BE49-F238E27FC236}">
-                <a16:creationId xmlns:a16="http://schemas.microsoft.com/office/drawing/2014/main" id="{1860CD38-C6B4-4FD7-B6D5-CBDBD6B2660F}"/>
-              </a:ext>
-            </a:extLst>
-          </p:cNvPr>
-          <p:cNvSpPr>
-            <a:spLocks xmlns:a="http://schemas.openxmlformats.org/drawingml/2006/main" noGrp="1"/>
-          </p:cNvSpPr>
-          <p:nvPr/>
-        </p:nvSpPr>
-        <p:spPr>
-          <a:xfrm xmlns:a="http://schemas.openxmlformats.org/drawingml/2006/main">
-            <a:off x="685800" y="533400"/>
-            <a:ext cx="9906000" cy="514350"/>
-          </a:xfrm>
-          <a:prstGeom xmlns:a="http://schemas.openxmlformats.org/drawingml/2006/main" prst="rect">
-            <a:avLst/>
-          </a:prstGeom>
-          <a:noFill xmlns:a="http://schemas.openxmlformats.org/drawingml/2006/main"/>
-          <a:ln xmlns:a="http://schemas.openxmlformats.org/drawingml/2006/main" w="0">
-            <a:noFill/>
-            <a:prstDash val="solid"/>
-          </a:ln>
-        </p:spPr>
-        <p:txBody>
-          <a:bodyPr xmlns:a="http://schemas.openxmlformats.org/drawingml/2006/main"/>
-          <a:lstStyle xmlns:a="http://schemas.openxmlformats.org/drawingml/2006/main"/>
-          <a:p xmlns:a="http://schemas.openxmlformats.org/drawingml/2006/main">
-            <a:pPr algn="l">
-              <a:defRPr sz="2850" b="1">
-                <a:solidFill>
-                  <a:srgbClr val="E6EFEB"/>
-                </a:solidFill>
-              </a:defRPr>
-            </a:pPr>
-            <a:r>
-              <a:rPr sz="2850" b="1">
-                <a:solidFill>
-                  <a:srgbClr val="E6EFEB"/>
-                </a:solidFill>
-              </a:rPr>
-              <a:t>Make the README feel like a complete application packet</a:t>
-            </a:r>
-          </a:p>
-        </p:txBody>
-      </p:sp>
-      <p:sp>
-        <p:nvSpPr>
-          <p:cNvPr id="2" name="">
-            <a:extLst xmlns:a="http://schemas.openxmlformats.org/drawingml/2006/main">
-              <a:ext uri="{FF2B5EF4-FFF2-40B4-BE49-F238E27FC236}">
-                <a16:creationId xmlns:a16="http://schemas.microsoft.com/office/drawing/2014/main" id="{CD3AC7E4-F798-49F1-8B40-9357691DF678}"/>
-              </a:ext>
-            </a:extLst>
-          </p:cNvPr>
-          <p:cNvSpPr>
-            <a:spLocks xmlns:a="http://schemas.openxmlformats.org/drawingml/2006/main" noGrp="1"/>
-          </p:cNvSpPr>
-          <p:nvPr/>
-        </p:nvSpPr>
-        <p:spPr>
-          <a:xfrm xmlns:a="http://schemas.openxmlformats.org/drawingml/2006/main">
-            <a:off x="914400" y="1447800"/>
-            <a:ext cx="3810000" cy="304800"/>
-          </a:xfrm>
-          <a:prstGeom xmlns:a="http://schemas.openxmlformats.org/drawingml/2006/main" prst="rect">
-            <a:avLst/>
-          </a:prstGeom>
-          <a:noFill xmlns:a="http://schemas.openxmlformats.org/drawingml/2006/main"/>
-          <a:ln xmlns:a="http://schemas.openxmlformats.org/drawingml/2006/main" w="0">
-            <a:noFill/>
-            <a:prstDash val="solid"/>
-          </a:ln>
-        </p:spPr>
-        <p:txBody>
-          <a:bodyPr xmlns:a="http://schemas.openxmlformats.org/drawingml/2006/main"/>
-          <a:lstStyle xmlns:a="http://schemas.openxmlformats.org/drawingml/2006/main"/>
-          <a:p xmlns:a="http://schemas.openxmlformats.org/drawingml/2006/main">
-            <a:pPr algn="l">
-              <a:defRPr sz="2100" b="1">
-                <a:solidFill>
-                  <a:srgbClr val="34D399"/>
-                </a:solidFill>
-              </a:defRPr>
-            </a:pPr>
-            <a:r>
-              <a:rPr sz="2100" b="1">
-                <a:solidFill>
-                  <a:srgbClr val="34D399"/>
-                </a:solidFill>
-              </a:rPr>
-              <a:t>README artifacts</a:t>
-            </a:r>
-          </a:p>
-        </p:txBody>
-      </p:sp>
-      <p:sp>
-        <p:nvSpPr>
-          <p:cNvPr id="3" name="">
-            <a:extLst xmlns:a="http://schemas.openxmlformats.org/drawingml/2006/main">
-              <a:ext uri="{FF2B5EF4-FFF2-40B4-BE49-F238E27FC236}">
-                <a16:creationId xmlns:a16="http://schemas.microsoft.com/office/drawing/2014/main" id="{075D0BCC-1A86-4D54-BE91-2B7FCA8C668E}"/>
-              </a:ext>
-            </a:extLst>
-          </p:cNvPr>
-          <p:cNvSpPr>
-            <a:spLocks xmlns:a="http://schemas.openxmlformats.org/drawingml/2006/main" noGrp="1"/>
-          </p:cNvSpPr>
-          <p:nvPr/>
-        </p:nvSpPr>
-        <p:spPr>
-          <a:xfrm xmlns:a="http://schemas.openxmlformats.org/drawingml/2006/main">
-            <a:off x="990600" y="2066925"/>
-            <a:ext cx="76200" cy="76200"/>
-          </a:xfrm>
-          <a:prstGeom xmlns:a="http://schemas.openxmlformats.org/drawingml/2006/main" prst="ellipse">
-            <a:avLst/>
-          </a:prstGeom>
-          <a:solidFill xmlns:a="http://schemas.openxmlformats.org/drawingml/2006/main">
-            <a:srgbClr val="34D399"/>
-          </a:solidFill>
-          <a:ln xmlns:a="http://schemas.openxmlformats.org/drawingml/2006/main" w="0">
-            <a:solidFill>
-              <a:srgbClr val="34D399"/>
-            </a:solidFill>
-            <a:prstDash val="solid"/>
-          </a:ln>
-        </p:spPr>
-      </p:sp>
-      <p:sp>
-        <p:nvSpPr>
-          <p:cNvPr id="4" name="">
-            <a:extLst xmlns:a="http://schemas.openxmlformats.org/drawingml/2006/main">
-              <a:ext uri="{FF2B5EF4-FFF2-40B4-BE49-F238E27FC236}">
-                <a16:creationId xmlns:a16="http://schemas.microsoft.com/office/drawing/2014/main" id="{22D9969F-FB56-4F0E-AD71-FA3035FC38D8}"/>
-              </a:ext>
-            </a:extLst>
-          </p:cNvPr>
-          <p:cNvSpPr>
-            <a:spLocks xmlns:a="http://schemas.openxmlformats.org/drawingml/2006/main" noGrp="1"/>
-          </p:cNvSpPr>
-          <p:nvPr/>
-        </p:nvSpPr>
-        <p:spPr>
-          <a:xfrm xmlns:a="http://schemas.openxmlformats.org/drawingml/2006/main">
-            <a:off x="1200150" y="2000250"/>
-            <a:ext cx="4552950" cy="419100"/>
-          </a:xfrm>
-          <a:prstGeom xmlns:a="http://schemas.openxmlformats.org/drawingml/2006/main" prst="rect">
-            <a:avLst/>
-          </a:prstGeom>
-          <a:noFill xmlns:a="http://schemas.openxmlformats.org/drawingml/2006/main"/>
-          <a:ln xmlns:a="http://schemas.openxmlformats.org/drawingml/2006/main" w="0">
-            <a:noFill/>
-            <a:prstDash val="solid"/>
-          </a:ln>
-        </p:spPr>
-        <p:txBody>
-          <a:bodyPr xmlns:a="http://schemas.openxmlformats.org/drawingml/2006/main"/>
-          <a:lstStyle xmlns:a="http://schemas.openxmlformats.org/drawingml/2006/main"/>
-          <a:p xmlns:a="http://schemas.openxmlformats.org/drawingml/2006/main">
-            <a:pPr algn="l">
-              <a:defRPr sz="1500" b="0">
-                <a:solidFill>
-                  <a:srgbClr val="E6EFEB"/>
-                </a:solidFill>
-              </a:defRPr>
-            </a:pPr>
-            <a:r>
-              <a:rPr sz="1500" b="0">
-                <a:solidFill>
-                  <a:srgbClr val="E6EFEB"/>
-                </a:solidFill>
-              </a:rPr>
-              <a:t>Live/local demo section with a realistic deployment note</a:t>
-            </a:r>
-          </a:p>
-        </p:txBody>
-      </p:sp>
-      <p:sp>
-        <p:nvSpPr>
-          <p:cNvPr id="5" name="">
-            <a:extLst xmlns:a="http://schemas.openxmlformats.org/drawingml/2006/main">
-              <a:ext uri="{FF2B5EF4-FFF2-40B4-BE49-F238E27FC236}">
-                <a16:creationId xmlns:a16="http://schemas.microsoft.com/office/drawing/2014/main" id="{18EA7032-30F1-4C16-BB21-95399C2C0753}"/>
-              </a:ext>
-            </a:extLst>
-          </p:cNvPr>
-          <p:cNvSpPr>
-            <a:spLocks xmlns:a="http://schemas.openxmlformats.org/drawingml/2006/main" noGrp="1"/>
-          </p:cNvSpPr>
-          <p:nvPr/>
-        </p:nvSpPr>
-        <p:spPr>
-          <a:xfrm xmlns:a="http://schemas.openxmlformats.org/drawingml/2006/main">
-            <a:off x="990600" y="2657475"/>
-            <a:ext cx="76200" cy="76200"/>
-          </a:xfrm>
-          <a:prstGeom xmlns:a="http://schemas.openxmlformats.org/drawingml/2006/main" prst="ellipse">
-            <a:avLst/>
-          </a:prstGeom>
-          <a:solidFill xmlns:a="http://schemas.openxmlformats.org/drawingml/2006/main">
-            <a:srgbClr val="34D399"/>
-          </a:solidFill>
-          <a:ln xmlns:a="http://schemas.openxmlformats.org/drawingml/2006/main" w="0">
-            <a:solidFill>
-              <a:srgbClr val="34D399"/>
-            </a:solidFill>
-            <a:prstDash val="solid"/>
-          </a:ln>
-        </p:spPr>
-      </p:sp>
-      <p:sp>
-        <p:nvSpPr>
-          <p:cNvPr id="6" name="">
-            <a:extLst xmlns:a="http://schemas.openxmlformats.org/drawingml/2006/main">
-              <a:ext uri="{FF2B5EF4-FFF2-40B4-BE49-F238E27FC236}">
-                <a16:creationId xmlns:a16="http://schemas.microsoft.com/office/drawing/2014/main" id="{C8DD4404-A5B2-4CDC-BBDA-C41902A0B422}"/>
-              </a:ext>
-            </a:extLst>
-          </p:cNvPr>
-          <p:cNvSpPr>
-            <a:spLocks xmlns:a="http://schemas.openxmlformats.org/drawingml/2006/main" noGrp="1"/>
-          </p:cNvSpPr>
-          <p:nvPr/>
-        </p:nvSpPr>
-        <p:spPr>
-          <a:xfrm xmlns:a="http://schemas.openxmlformats.org/drawingml/2006/main">
-            <a:off x="1200150" y="2590800"/>
-            <a:ext cx="4552950" cy="419100"/>
-          </a:xfrm>
-          <a:prstGeom xmlns:a="http://schemas.openxmlformats.org/drawingml/2006/main" prst="rect">
-            <a:avLst/>
-          </a:prstGeom>
-          <a:noFill xmlns:a="http://schemas.openxmlformats.org/drawingml/2006/main"/>
-          <a:ln xmlns:a="http://schemas.openxmlformats.org/drawingml/2006/main" w="0">
-            <a:noFill/>
-            <a:prstDash val="solid"/>
-          </a:ln>
-        </p:spPr>
-        <p:txBody>
-          <a:bodyPr xmlns:a="http://schemas.openxmlformats.org/drawingml/2006/main"/>
-          <a:lstStyle xmlns:a="http://schemas.openxmlformats.org/drawingml/2006/main"/>
-          <a:p xmlns:a="http://schemas.openxmlformats.org/drawingml/2006/main">
-            <a:pPr algn="l">
-              <a:defRPr sz="1500" b="0">
-                <a:solidFill>
-                  <a:srgbClr val="E6EFEB"/>
-                </a:solidFill>
-              </a:defRPr>
-            </a:pPr>
-            <a:r>
-              <a:rPr sz="1500" b="0">
-                <a:solidFill>
-                  <a:srgbClr val="E6EFEB"/>
-                </a:solidFill>
-              </a:rPr>
-              <a:t>Architecture diagram plus plain-English walkthrough</a:t>
-            </a:r>
-          </a:p>
-        </p:txBody>
-      </p:sp>
-      <p:sp>
-        <p:nvSpPr>
-          <p:cNvPr id="7" name="">
-            <a:extLst xmlns:a="http://schemas.openxmlformats.org/drawingml/2006/main">
-              <a:ext uri="{FF2B5EF4-FFF2-40B4-BE49-F238E27FC236}">
-                <a16:creationId xmlns:a16="http://schemas.microsoft.com/office/drawing/2014/main" id="{44424D4E-E2C8-48B1-A439-BB100E48F3FB}"/>
-              </a:ext>
-            </a:extLst>
-          </p:cNvPr>
-          <p:cNvSpPr>
-            <a:spLocks xmlns:a="http://schemas.openxmlformats.org/drawingml/2006/main" noGrp="1"/>
-          </p:cNvSpPr>
-          <p:nvPr/>
-        </p:nvSpPr>
-        <p:spPr>
-          <a:xfrm xmlns:a="http://schemas.openxmlformats.org/drawingml/2006/main">
-            <a:off x="990600" y="3248025"/>
-            <a:ext cx="76200" cy="76200"/>
-          </a:xfrm>
-          <a:prstGeom xmlns:a="http://schemas.openxmlformats.org/drawingml/2006/main" prst="ellipse">
-            <a:avLst/>
-          </a:prstGeom>
-          <a:solidFill xmlns:a="http://schemas.openxmlformats.org/drawingml/2006/main">
-            <a:srgbClr val="34D399"/>
-          </a:solidFill>
-          <a:ln xmlns:a="http://schemas.openxmlformats.org/drawingml/2006/main" w="0">
-            <a:solidFill>
-              <a:srgbClr val="34D399"/>
-            </a:solidFill>
-            <a:prstDash val="solid"/>
-          </a:ln>
-        </p:spPr>
-      </p:sp>
-      <p:sp>
-        <p:nvSpPr>
-          <p:cNvPr id="8" name="">
-            <a:extLst xmlns:a="http://schemas.openxmlformats.org/drawingml/2006/main">
-              <a:ext uri="{FF2B5EF4-FFF2-40B4-BE49-F238E27FC236}">
-                <a16:creationId xmlns:a16="http://schemas.microsoft.com/office/drawing/2014/main" id="{8942663A-DC77-444D-9F08-2C5D65E71F39}"/>
-              </a:ext>
-            </a:extLst>
-          </p:cNvPr>
-          <p:cNvSpPr>
-            <a:spLocks xmlns:a="http://schemas.openxmlformats.org/drawingml/2006/main" noGrp="1"/>
-          </p:cNvSpPr>
-          <p:nvPr/>
-        </p:nvSpPr>
-        <p:spPr>
-          <a:xfrm xmlns:a="http://schemas.openxmlformats.org/drawingml/2006/main">
-            <a:off x="1200150" y="3181350"/>
-            <a:ext cx="4552950" cy="419100"/>
-          </a:xfrm>
-          <a:prstGeom xmlns:a="http://schemas.openxmlformats.org/drawingml/2006/main" prst="rect">
-            <a:avLst/>
-          </a:prstGeom>
-          <a:noFill xmlns:a="http://schemas.openxmlformats.org/drawingml/2006/main"/>
-          <a:ln xmlns:a="http://schemas.openxmlformats.org/drawingml/2006/main" w="0">
-            <a:noFill/>
-            <a:prstDash val="solid"/>
-          </a:ln>
-        </p:spPr>
-        <p:txBody>
-          <a:bodyPr xmlns:a="http://schemas.openxmlformats.org/drawingml/2006/main"/>
-          <a:lstStyle xmlns:a="http://schemas.openxmlformats.org/drawingml/2006/main"/>
-          <a:p xmlns:a="http://schemas.openxmlformats.org/drawingml/2006/main">
-            <a:pPr algn="l">
-              <a:defRPr sz="1500" b="0">
-                <a:solidFill>
-                  <a:srgbClr val="E6EFEB"/>
-                </a:solidFill>
-              </a:defRPr>
-            </a:pPr>
-            <a:r>
-              <a:rPr sz="1500" b="0">
-                <a:solidFill>
-                  <a:srgbClr val="E6EFEB"/>
-                </a:solidFill>
-              </a:rPr>
-              <a:t>Evaluation report with command, score, failures, and sample transcripts</a:t>
-            </a:r>
-          </a:p>
-        </p:txBody>
-      </p:sp>
-      <p:sp>
-        <p:nvSpPr>
-          <p:cNvPr id="9" name="">
-            <a:extLst xmlns:a="http://schemas.openxmlformats.org/drawingml/2006/main">
-              <a:ext uri="{FF2B5EF4-FFF2-40B4-BE49-F238E27FC236}">
-                <a16:creationId xmlns:a16="http://schemas.microsoft.com/office/drawing/2014/main" id="{7CF71645-1897-4040-9F01-C9AC33B3F610}"/>
-              </a:ext>
-            </a:extLst>
-          </p:cNvPr>
-          <p:cNvSpPr>
-            <a:spLocks xmlns:a="http://schemas.openxmlformats.org/drawingml/2006/main" noGrp="1"/>
-          </p:cNvSpPr>
-          <p:nvPr/>
-        </p:nvSpPr>
-        <p:spPr>
-          <a:xfrm xmlns:a="http://schemas.openxmlformats.org/drawingml/2006/main">
-            <a:off x="990600" y="3838575"/>
-            <a:ext cx="76200" cy="76200"/>
-          </a:xfrm>
-          <a:prstGeom xmlns:a="http://schemas.openxmlformats.org/drawingml/2006/main" prst="ellipse">
-            <a:avLst/>
-          </a:prstGeom>
-          <a:solidFill xmlns:a="http://schemas.openxmlformats.org/drawingml/2006/main">
-            <a:srgbClr val="34D399"/>
-          </a:solidFill>
-          <a:ln xmlns:a="http://schemas.openxmlformats.org/drawingml/2006/main" w="0">
-            <a:solidFill>
-              <a:srgbClr val="34D399"/>
-            </a:solidFill>
-            <a:prstDash val="solid"/>
-          </a:ln>
-        </p:spPr>
-      </p:sp>
-      <p:sp>
-        <p:nvSpPr>
-          <p:cNvPr id="10" name="">
-            <a:extLst xmlns:a="http://schemas.openxmlformats.org/drawingml/2006/main">
-              <a:ext uri="{FF2B5EF4-FFF2-40B4-BE49-F238E27FC236}">
-                <a16:creationId xmlns:a16="http://schemas.microsoft.com/office/drawing/2014/main" id="{8D2388F7-7FED-4173-945C-57D99F2B11AD}"/>
-              </a:ext>
-            </a:extLst>
-          </p:cNvPr>
-          <p:cNvSpPr>
-            <a:spLocks xmlns:a="http://schemas.openxmlformats.org/drawingml/2006/main" noGrp="1"/>
-          </p:cNvSpPr>
-          <p:nvPr/>
-        </p:nvSpPr>
-        <p:spPr>
-          <a:xfrm xmlns:a="http://schemas.openxmlformats.org/drawingml/2006/main">
-            <a:off x="1200150" y="3771900"/>
-            <a:ext cx="4552950" cy="419100"/>
-          </a:xfrm>
-          <a:prstGeom xmlns:a="http://schemas.openxmlformats.org/drawingml/2006/main" prst="rect">
-            <a:avLst/>
-          </a:prstGeom>
-          <a:noFill xmlns:a="http://schemas.openxmlformats.org/drawingml/2006/main"/>
-          <a:ln xmlns:a="http://schemas.openxmlformats.org/drawingml/2006/main" w="0">
-            <a:noFill/>
-            <a:prstDash val="solid"/>
-          </a:ln>
-        </p:spPr>
-        <p:txBody>
-          <a:bodyPr xmlns:a="http://schemas.openxmlformats.org/drawingml/2006/main"/>
-          <a:lstStyle xmlns:a="http://schemas.openxmlformats.org/drawingml/2006/main"/>
-          <a:p xmlns:a="http://schemas.openxmlformats.org/drawingml/2006/main">
-            <a:pPr algn="l">
-              <a:defRPr sz="1500" b="0">
-                <a:solidFill>
-                  <a:srgbClr val="E6EFEB"/>
-                </a:solidFill>
-              </a:defRPr>
-            </a:pPr>
-            <a:r>
-              <a:rPr sz="1500" b="0">
-                <a:solidFill>
-                  <a:srgbClr val="E6EFEB"/>
-                </a:solidFill>
-              </a:rPr>
-              <a:t>Short video link and three-scenario demo script</a:t>
-            </a:r>
-          </a:p>
-        </p:txBody>
-      </p:sp>
-      <p:sp>
-        <p:nvSpPr>
-          <p:cNvPr id="11" name="">
-            <a:extLst xmlns:a="http://schemas.openxmlformats.org/drawingml/2006/main">
-              <a:ext uri="{FF2B5EF4-FFF2-40B4-BE49-F238E27FC236}">
-                <a16:creationId xmlns:a16="http://schemas.microsoft.com/office/drawing/2014/main" id="{9C295311-14AD-4D0B-8E18-A8613C44F533}"/>
-              </a:ext>
-            </a:extLst>
-          </p:cNvPr>
-          <p:cNvSpPr>
-            <a:spLocks xmlns:a="http://schemas.openxmlformats.org/drawingml/2006/main" noGrp="1"/>
-          </p:cNvSpPr>
-          <p:nvPr/>
-        </p:nvSpPr>
-        <p:spPr>
-          <a:xfrm xmlns:a="http://schemas.openxmlformats.org/drawingml/2006/main">
-            <a:off x="6553200" y="1447800"/>
-            <a:ext cx="3810000" cy="304800"/>
-          </a:xfrm>
-          <a:prstGeom xmlns:a="http://schemas.openxmlformats.org/drawingml/2006/main" prst="rect">
-            <a:avLst/>
-          </a:prstGeom>
-          <a:noFill xmlns:a="http://schemas.openxmlformats.org/drawingml/2006/main"/>
-          <a:ln xmlns:a="http://schemas.openxmlformats.org/drawingml/2006/main" w="0">
-            <a:noFill/>
-            <a:prstDash val="solid"/>
-          </a:ln>
-        </p:spPr>
-        <p:txBody>
-          <a:bodyPr xmlns:a="http://schemas.openxmlformats.org/drawingml/2006/main"/>
-          <a:lstStyle xmlns:a="http://schemas.openxmlformats.org/drawingml/2006/main"/>
-          <a:p xmlns:a="http://schemas.openxmlformats.org/drawingml/2006/main">
-            <a:pPr algn="l">
-              <a:defRPr sz="2100" b="1">
-                <a:solidFill>
-                  <a:srgbClr val="34D399"/>
-                </a:solidFill>
-              </a:defRPr>
-            </a:pPr>
-            <a:r>
-              <a:rPr sz="2100" b="1">
-                <a:solidFill>
-                  <a:srgbClr val="34D399"/>
-                </a:solidFill>
-              </a:rPr>
-              <a:t>Proof artifacts</a:t>
-            </a:r>
-          </a:p>
-        </p:txBody>
-      </p:sp>
-      <p:sp>
-        <p:nvSpPr>
-          <p:cNvPr id="12" name="">
-            <a:extLst xmlns:a="http://schemas.openxmlformats.org/drawingml/2006/main">
-              <a:ext uri="{FF2B5EF4-FFF2-40B4-BE49-F238E27FC236}">
-                <a16:creationId xmlns:a16="http://schemas.microsoft.com/office/drawing/2014/main" id="{BBC613C9-09A0-4042-A67F-76B034EE6300}"/>
-              </a:ext>
-            </a:extLst>
-          </p:cNvPr>
-          <p:cNvSpPr>
-            <a:spLocks xmlns:a="http://schemas.openxmlformats.org/drawingml/2006/main" noGrp="1"/>
-          </p:cNvSpPr>
-          <p:nvPr/>
-        </p:nvSpPr>
-        <p:spPr>
-          <a:xfrm xmlns:a="http://schemas.openxmlformats.org/drawingml/2006/main">
-            <a:off x="6629400" y="2066925"/>
-            <a:ext cx="76200" cy="76200"/>
-          </a:xfrm>
-          <a:prstGeom xmlns:a="http://schemas.openxmlformats.org/drawingml/2006/main" prst="ellipse">
-            <a:avLst/>
-          </a:prstGeom>
-          <a:solidFill xmlns:a="http://schemas.openxmlformats.org/drawingml/2006/main">
-            <a:srgbClr val="60A5FA"/>
-          </a:solidFill>
-          <a:ln xmlns:a="http://schemas.openxmlformats.org/drawingml/2006/main" w="0">
-            <a:solidFill>
-              <a:srgbClr val="60A5FA"/>
-            </a:solidFill>
-            <a:prstDash val="solid"/>
-          </a:ln>
-        </p:spPr>
-      </p:sp>
-      <p:sp>
-        <p:nvSpPr>
-          <p:cNvPr id="13" name="">
-            <a:extLst xmlns:a="http://schemas.openxmlformats.org/drawingml/2006/main">
-              <a:ext uri="{FF2B5EF4-FFF2-40B4-BE49-F238E27FC236}">
-                <a16:creationId xmlns:a16="http://schemas.microsoft.com/office/drawing/2014/main" id="{CF408324-33B7-42C7-97B6-0E375A17068D}"/>
-              </a:ext>
-            </a:extLst>
-          </p:cNvPr>
-          <p:cNvSpPr>
-            <a:spLocks xmlns:a="http://schemas.openxmlformats.org/drawingml/2006/main" noGrp="1"/>
-          </p:cNvSpPr>
-          <p:nvPr/>
-        </p:nvSpPr>
-        <p:spPr>
-          <a:xfrm xmlns:a="http://schemas.openxmlformats.org/drawingml/2006/main">
-            <a:off x="6838950" y="2000250"/>
-            <a:ext cx="4362450" cy="419100"/>
-          </a:xfrm>
-          <a:prstGeom xmlns:a="http://schemas.openxmlformats.org/drawingml/2006/main" prst="rect">
-            <a:avLst/>
-          </a:prstGeom>
-          <a:noFill xmlns:a="http://schemas.openxmlformats.org/drawingml/2006/main"/>
-          <a:ln xmlns:a="http://schemas.openxmlformats.org/drawingml/2006/main" w="0">
-            <a:noFill/>
-            <a:prstDash val="solid"/>
-          </a:ln>
-        </p:spPr>
-        <p:txBody>
-          <a:bodyPr xmlns:a="http://schemas.openxmlformats.org/drawingml/2006/main"/>
-          <a:lstStyle xmlns:a="http://schemas.openxmlformats.org/drawingml/2006/main"/>
-          <a:p xmlns:a="http://schemas.openxmlformats.org/drawingml/2006/main">
-            <a:pPr algn="l">
-              <a:defRPr sz="1500" b="0">
-                <a:solidFill>
-                  <a:srgbClr val="E6EFEB"/>
-                </a:solidFill>
-              </a:defRPr>
-            </a:pPr>
-            <a:r>
-              <a:rPr sz="1500" b="0">
-                <a:solidFill>
-                  <a:srgbClr val="E6EFEB"/>
-                </a:solidFill>
-              </a:rPr>
-              <a:t>Production note: TMC/Vonage project covers live telephony</a:t>
-            </a:r>
-          </a:p>
-        </p:txBody>
-      </p:sp>
-      <p:sp>
-        <p:nvSpPr>
-          <p:cNvPr id="14" name="">
-            <a:extLst xmlns:a="http://schemas.openxmlformats.org/drawingml/2006/main">
-              <a:ext uri="{FF2B5EF4-FFF2-40B4-BE49-F238E27FC236}">
-                <a16:creationId xmlns:a16="http://schemas.microsoft.com/office/drawing/2014/main" id="{E2A1A765-9EB8-4E2C-A178-C9657E543CEF}"/>
-              </a:ext>
-            </a:extLst>
-          </p:cNvPr>
-          <p:cNvSpPr>
-            <a:spLocks xmlns:a="http://schemas.openxmlformats.org/drawingml/2006/main" noGrp="1"/>
-          </p:cNvSpPr>
-          <p:nvPr/>
-        </p:nvSpPr>
-        <p:spPr>
-          <a:xfrm xmlns:a="http://schemas.openxmlformats.org/drawingml/2006/main">
-            <a:off x="6629400" y="2657475"/>
-            <a:ext cx="76200" cy="76200"/>
-          </a:xfrm>
-          <a:prstGeom xmlns:a="http://schemas.openxmlformats.org/drawingml/2006/main" prst="ellipse">
-            <a:avLst/>
-          </a:prstGeom>
-          <a:solidFill xmlns:a="http://schemas.openxmlformats.org/drawingml/2006/main">
-            <a:srgbClr val="60A5FA"/>
-          </a:solidFill>
-          <a:ln xmlns:a="http://schemas.openxmlformats.org/drawingml/2006/main" w="0">
-            <a:solidFill>
-              <a:srgbClr val="60A5FA"/>
-            </a:solidFill>
-            <a:prstDash val="solid"/>
-          </a:ln>
-        </p:spPr>
-      </p:sp>
-      <p:sp>
-        <p:nvSpPr>
-          <p:cNvPr id="15" name="">
-            <a:extLst xmlns:a="http://schemas.openxmlformats.org/drawingml/2006/main">
-              <a:ext uri="{FF2B5EF4-FFF2-40B4-BE49-F238E27FC236}">
-                <a16:creationId xmlns:a16="http://schemas.microsoft.com/office/drawing/2014/main" id="{DCD4A539-715E-49CA-B566-02399E735107}"/>
-              </a:ext>
-            </a:extLst>
-          </p:cNvPr>
-          <p:cNvSpPr>
-            <a:spLocks xmlns:a="http://schemas.openxmlformats.org/drawingml/2006/main" noGrp="1"/>
-          </p:cNvSpPr>
-          <p:nvPr/>
-        </p:nvSpPr>
-        <p:spPr>
-          <a:xfrm xmlns:a="http://schemas.openxmlformats.org/drawingml/2006/main">
-            <a:off x="6838950" y="2590800"/>
-            <a:ext cx="4362450" cy="419100"/>
-          </a:xfrm>
-          <a:prstGeom xmlns:a="http://schemas.openxmlformats.org/drawingml/2006/main" prst="rect">
-            <a:avLst/>
-          </a:prstGeom>
-          <a:noFill xmlns:a="http://schemas.openxmlformats.org/drawingml/2006/main"/>
-          <a:ln xmlns:a="http://schemas.openxmlformats.org/drawingml/2006/main" w="0">
-            <a:noFill/>
-            <a:prstDash val="solid"/>
-          </a:ln>
-        </p:spPr>
-        <p:txBody>
-          <a:bodyPr xmlns:a="http://schemas.openxmlformats.org/drawingml/2006/main"/>
-          <a:lstStyle xmlns:a="http://schemas.openxmlformats.org/drawingml/2006/main"/>
-          <a:p xmlns:a="http://schemas.openxmlformats.org/drawingml/2006/main">
-            <a:pPr algn="l">
-              <a:defRPr sz="1500" b="0">
-                <a:solidFill>
-                  <a:srgbClr val="E6EFEB"/>
-                </a:solidFill>
-              </a:defRPr>
-            </a:pPr>
-            <a:r>
-              <a:rPr sz="1500" b="0">
-                <a:solidFill>
-                  <a:srgbClr val="E6EFEB"/>
-                </a:solidFill>
-              </a:rPr>
-              <a:t>CI badge for pytest, ruff, mypy</a:t>
-            </a:r>
-          </a:p>
-        </p:txBody>
-      </p:sp>
-      <p:sp>
-        <p:nvSpPr>
-          <p:cNvPr id="16" name="">
-            <a:extLst xmlns:a="http://schemas.openxmlformats.org/drawingml/2006/main">
-              <a:ext uri="{FF2B5EF4-FFF2-40B4-BE49-F238E27FC236}">
-                <a16:creationId xmlns:a16="http://schemas.microsoft.com/office/drawing/2014/main" id="{410A6788-24AD-44F0-A159-4D0A82753B4D}"/>
-              </a:ext>
-            </a:extLst>
-          </p:cNvPr>
-          <p:cNvSpPr>
-            <a:spLocks xmlns:a="http://schemas.openxmlformats.org/drawingml/2006/main" noGrp="1"/>
-          </p:cNvSpPr>
-          <p:nvPr/>
-        </p:nvSpPr>
-        <p:spPr>
-          <a:xfrm xmlns:a="http://schemas.openxmlformats.org/drawingml/2006/main">
-            <a:off x="6629400" y="3248025"/>
-            <a:ext cx="76200" cy="76200"/>
-          </a:xfrm>
-          <a:prstGeom xmlns:a="http://schemas.openxmlformats.org/drawingml/2006/main" prst="ellipse">
-            <a:avLst/>
-          </a:prstGeom>
-          <a:solidFill xmlns:a="http://schemas.openxmlformats.org/drawingml/2006/main">
-            <a:srgbClr val="60A5FA"/>
-          </a:solidFill>
-          <a:ln xmlns:a="http://schemas.openxmlformats.org/drawingml/2006/main" w="0">
-            <a:solidFill>
-              <a:srgbClr val="60A5FA"/>
-            </a:solidFill>
-            <a:prstDash val="solid"/>
-          </a:ln>
-        </p:spPr>
-      </p:sp>
-      <p:sp>
-        <p:nvSpPr>
-          <p:cNvPr id="17" name="">
-            <a:extLst xmlns:a="http://schemas.openxmlformats.org/drawingml/2006/main">
-              <a:ext uri="{FF2B5EF4-FFF2-40B4-BE49-F238E27FC236}">
-                <a16:creationId xmlns:a16="http://schemas.microsoft.com/office/drawing/2014/main" id="{4D7663D8-E82B-434D-BC75-9ADFF082A065}"/>
-              </a:ext>
-            </a:extLst>
-          </p:cNvPr>
-          <p:cNvSpPr>
-            <a:spLocks xmlns:a="http://schemas.openxmlformats.org/drawingml/2006/main" noGrp="1"/>
-          </p:cNvSpPr>
-          <p:nvPr/>
-        </p:nvSpPr>
-        <p:spPr>
-          <a:xfrm xmlns:a="http://schemas.openxmlformats.org/drawingml/2006/main">
-            <a:off x="6838950" y="3181350"/>
-            <a:ext cx="4362450" cy="419100"/>
-          </a:xfrm>
-          <a:prstGeom xmlns:a="http://schemas.openxmlformats.org/drawingml/2006/main" prst="rect">
-            <a:avLst/>
-          </a:prstGeom>
-          <a:noFill xmlns:a="http://schemas.openxmlformats.org/drawingml/2006/main"/>
-          <a:ln xmlns:a="http://schemas.openxmlformats.org/drawingml/2006/main" w="0">
-            <a:noFill/>
-            <a:prstDash val="solid"/>
-          </a:ln>
-        </p:spPr>
-        <p:txBody>
-          <a:bodyPr xmlns:a="http://schemas.openxmlformats.org/drawingml/2006/main"/>
-          <a:lstStyle xmlns:a="http://schemas.openxmlformats.org/drawingml/2006/main"/>
-          <a:p xmlns:a="http://schemas.openxmlformats.org/drawingml/2006/main">
-            <a:pPr algn="l">
-              <a:defRPr sz="1500" b="0">
-                <a:solidFill>
-                  <a:srgbClr val="E6EFEB"/>
-                </a:solidFill>
-              </a:defRPr>
-            </a:pPr>
-            <a:r>
-              <a:rPr sz="1500" b="0">
-                <a:solidFill>
-                  <a:srgbClr val="E6EFEB"/>
-                </a:solidFill>
-              </a:rPr>
-              <a:t>Implemented vs planned matrix</a:t>
-            </a:r>
-          </a:p>
-        </p:txBody>
-      </p:sp>
-      <p:sp>
-        <p:nvSpPr>
-          <p:cNvPr id="18" name="">
-            <a:extLst xmlns:a="http://schemas.openxmlformats.org/drawingml/2006/main">
-              <a:ext uri="{FF2B5EF4-FFF2-40B4-BE49-F238E27FC236}">
-                <a16:creationId xmlns:a16="http://schemas.microsoft.com/office/drawing/2014/main" id="{D236FF20-3B03-477B-941A-CEE9AD5E93BE}"/>
-              </a:ext>
-            </a:extLst>
-          </p:cNvPr>
-          <p:cNvSpPr>
-            <a:spLocks xmlns:a="http://schemas.openxmlformats.org/drawingml/2006/main" noGrp="1"/>
-          </p:cNvSpPr>
-          <p:nvPr/>
-        </p:nvSpPr>
-        <p:spPr>
-          <a:xfrm xmlns:a="http://schemas.openxmlformats.org/drawingml/2006/main">
-            <a:off x="6629400" y="3838575"/>
-            <a:ext cx="76200" cy="76200"/>
-          </a:xfrm>
-          <a:prstGeom xmlns:a="http://schemas.openxmlformats.org/drawingml/2006/main" prst="ellipse">
-            <a:avLst/>
-          </a:prstGeom>
-          <a:solidFill xmlns:a="http://schemas.openxmlformats.org/drawingml/2006/main">
-            <a:srgbClr val="60A5FA"/>
-          </a:solidFill>
-          <a:ln xmlns:a="http://schemas.openxmlformats.org/drawingml/2006/main" w="0">
-            <a:solidFill>
-              <a:srgbClr val="60A5FA"/>
-            </a:solidFill>
-            <a:prstDash val="solid"/>
-          </a:ln>
-        </p:spPr>
-      </p:sp>
-      <p:sp>
-        <p:nvSpPr>
-          <p:cNvPr id="19" name="">
-            <a:extLst xmlns:a="http://schemas.openxmlformats.org/drawingml/2006/main">
-              <a:ext uri="{FF2B5EF4-FFF2-40B4-BE49-F238E27FC236}">
-                <a16:creationId xmlns:a16="http://schemas.microsoft.com/office/drawing/2014/main" id="{3EC2AADB-40F3-4628-96AE-8550EAC360AD}"/>
-              </a:ext>
-            </a:extLst>
-          </p:cNvPr>
-          <p:cNvSpPr>
-            <a:spLocks xmlns:a="http://schemas.openxmlformats.org/drawingml/2006/main" noGrp="1"/>
-          </p:cNvSpPr>
-          <p:nvPr/>
-        </p:nvSpPr>
-        <p:spPr>
-          <a:xfrm xmlns:a="http://schemas.openxmlformats.org/drawingml/2006/main">
-            <a:off x="6838950" y="3771900"/>
-            <a:ext cx="4362450" cy="419100"/>
-          </a:xfrm>
-          <a:prstGeom xmlns:a="http://schemas.openxmlformats.org/drawingml/2006/main" prst="rect">
-            <a:avLst/>
-          </a:prstGeom>
-          <a:noFill xmlns:a="http://schemas.openxmlformats.org/drawingml/2006/main"/>
-          <a:ln xmlns:a="http://schemas.openxmlformats.org/drawingml/2006/main" w="0">
-            <a:noFill/>
-            <a:prstDash val="solid"/>
-          </a:ln>
-        </p:spPr>
-        <p:txBody>
-          <a:bodyPr xmlns:a="http://schemas.openxmlformats.org/drawingml/2006/main"/>
-          <a:lstStyle xmlns:a="http://schemas.openxmlformats.org/drawingml/2006/main"/>
-          <a:p xmlns:a="http://schemas.openxmlformats.org/drawingml/2006/main">
-            <a:pPr algn="l">
-              <a:defRPr sz="1500" b="0">
-                <a:solidFill>
-                  <a:srgbClr val="E6EFEB"/>
-                </a:solidFill>
-              </a:defRPr>
-            </a:pPr>
-            <a:r>
-              <a:rPr sz="1500" b="0">
-                <a:solidFill>
-                  <a:srgbClr val="E6EFEB"/>
-                </a:solidFill>
-              </a:rPr>
-              <a:t>One-page application case study for Acto-style revenue workflows</a:t>
-            </a:r>
-          </a:p>
-        </p:txBody>
-      </p:sp>
-      <p:sp>
-        <p:nvSpPr>
-          <p:cNvPr id="20" name="">
-            <a:extLst xmlns:a="http://schemas.openxmlformats.org/drawingml/2006/main">
-              <a:ext uri="{FF2B5EF4-FFF2-40B4-BE49-F238E27FC236}">
-                <a16:creationId xmlns:a16="http://schemas.microsoft.com/office/drawing/2014/main" id="{B8A574AA-2080-4192-A3EC-6396953499CA}"/>
-              </a:ext>
-            </a:extLst>
-          </p:cNvPr>
-          <p:cNvSpPr>
-            <a:spLocks xmlns:a="http://schemas.openxmlformats.org/drawingml/2006/main" noGrp="1"/>
-          </p:cNvSpPr>
-          <p:nvPr/>
-        </p:nvSpPr>
-        <p:spPr>
-          <a:xfrm xmlns:a="http://schemas.openxmlformats.org/drawingml/2006/main">
-            <a:off x="1066800" y="5829300"/>
-            <a:ext cx="8953500" cy="342900"/>
-          </a:xfrm>
-          <a:prstGeom xmlns:a="http://schemas.openxmlformats.org/drawingml/2006/main" prst="rect">
-            <a:avLst/>
-          </a:prstGeom>
-          <a:noFill xmlns:a="http://schemas.openxmlformats.org/drawingml/2006/main"/>
-          <a:ln xmlns:a="http://schemas.openxmlformats.org/drawingml/2006/main" w="0">
-            <a:noFill/>
-            <a:prstDash val="solid"/>
-          </a:ln>
-        </p:spPr>
-        <p:txBody>
-          <a:bodyPr xmlns:a="http://schemas.openxmlformats.org/drawingml/2006/main"/>
-          <a:lstStyle xmlns:a="http://schemas.openxmlformats.org/drawingml/2006/main"/>
-          <a:p xmlns:a="http://schemas.openxmlformats.org/drawingml/2006/main">
-            <a:pPr algn="l">
-              <a:defRPr sz="1800" b="1">
-                <a:solidFill>
-                  <a:srgbClr val="E6EFEB"/>
-                </a:solidFill>
-              </a:defRPr>
-            </a:pPr>
-            <a:r>
-              <a:rPr sz="1800" b="1">
-                <a:solidFill>
-                  <a:srgbClr val="E6EFEB"/>
-                </a:solidFill>
-              </a:rPr>
-              <a:t>Positioning: this repo proves the architecture and eval discipline; TMC proves production telephony.</a:t>
-            </a:r>
-          </a:p>
-        </p:txBody>
-      </p:sp>
-      <p:sp>
-        <p:nvSpPr>
-          <p:cNvPr id="21" name="">
-            <a:extLst xmlns:a="http://schemas.openxmlformats.org/drawingml/2006/main">
-              <a:ext uri="{FF2B5EF4-FFF2-40B4-BE49-F238E27FC236}">
-                <a16:creationId xmlns:a16="http://schemas.microsoft.com/office/drawing/2014/main" id="{4FC59639-E7CF-4E4C-A83E-804A7707D51B}"/>
-              </a:ext>
-            </a:extLst>
-          </p:cNvPr>
-          <p:cNvSpPr>
-            <a:spLocks xmlns:a="http://schemas.openxmlformats.org/drawingml/2006/main" noGrp="1"/>
-          </p:cNvSpPr>
-          <p:nvPr/>
-        </p:nvSpPr>
-        <p:spPr>
-          <a:xfrm xmlns:a="http://schemas.openxmlformats.org/drawingml/2006/main">
-            <a:off x="685800" y="6324600"/>
-            <a:ext cx="2095500" cy="228600"/>
-          </a:xfrm>
-          <a:prstGeom xmlns:a="http://schemas.openxmlformats.org/drawingml/2006/main" prst="rect">
-            <a:avLst/>
-          </a:prstGeom>
-          <a:noFill xmlns:a="http://schemas.openxmlformats.org/drawingml/2006/main"/>
-          <a:ln xmlns:a="http://schemas.openxmlformats.org/drawingml/2006/main" w="0">
-            <a:noFill/>
-            <a:prstDash val="solid"/>
-          </a:ln>
-        </p:spPr>
-        <p:txBody>
-          <a:bodyPr xmlns:a="http://schemas.openxmlformats.org/drawingml/2006/main"/>
-          <a:lstStyle xmlns:a="http://schemas.openxmlformats.org/drawingml/2006/main"/>
-          <a:p xmlns:a="http://schemas.openxmlformats.org/drawingml/2006/main">
-            <a:pPr algn="l">
-              <a:defRPr sz="1050" b="1">
-                <a:solidFill>
-                  <a:srgbClr val="8CA098"/>
-                </a:solidFill>
-              </a:defRPr>
-            </a:pPr>
-            <a:r>
-              <a:rPr sz="1050" b="1">
-                <a:solidFill>
-                  <a:srgbClr val="8CA098"/>
-                </a:solidFill>
-              </a:rPr>
-              <a:t>voice-agent</a:t>
-            </a:r>
-          </a:p>
-        </p:txBody>
-      </p:sp>
-      <p:sp>
-        <p:nvSpPr>
-          <p:cNvPr id="22" name="">
-            <a:extLst xmlns:a="http://schemas.openxmlformats.org/drawingml/2006/main">
-              <a:ext uri="{FF2B5EF4-FFF2-40B4-BE49-F238E27FC236}">
-                <a16:creationId xmlns:a16="http://schemas.microsoft.com/office/drawing/2014/main" id="{ECCD3289-2E84-4DC5-9DAC-57EC025C7EEC}"/>
-              </a:ext>
-            </a:extLst>
-          </p:cNvPr>
-          <p:cNvSpPr>
-            <a:spLocks xmlns:a="http://schemas.openxmlformats.org/drawingml/2006/main" noGrp="1"/>
-          </p:cNvSpPr>
-          <p:nvPr/>
-        </p:nvSpPr>
-        <p:spPr>
-          <a:xfrm xmlns:a="http://schemas.openxmlformats.org/drawingml/2006/main">
-            <a:off x="10915650" y="6324600"/>
-            <a:ext cx="590550" cy="228600"/>
-          </a:xfrm>
-          <a:prstGeom xmlns:a="http://schemas.openxmlformats.org/drawingml/2006/main" prst="rect">
-            <a:avLst/>
-          </a:prstGeom>
-          <a:noFill xmlns:a="http://schemas.openxmlformats.org/drawingml/2006/main"/>
-          <a:ln xmlns:a="http://schemas.openxmlformats.org/drawingml/2006/main" w="0">
-            <a:noFill/>
-            <a:prstDash val="solid"/>
-          </a:ln>
-        </p:spPr>
-        <p:txBody>
-          <a:bodyPr xmlns:a="http://schemas.openxmlformats.org/drawingml/2006/main"/>
-          <a:lstStyle xmlns:a="http://schemas.openxmlformats.org/drawingml/2006/main"/>
-          <a:p xmlns:a="http://schemas.openxmlformats.org/drawingml/2006/main">
-            <a:pPr algn="r">
-              <a:defRPr sz="1050" b="0">
-                <a:solidFill>
-                  <a:srgbClr val="8CA098"/>
-                </a:solidFill>
-              </a:defRPr>
-            </a:pPr>
-            <a:r>
-              <a:rPr sz="1050" b="0">
-                <a:solidFill>
-                  <a:srgbClr val="8CA098"/>
-                </a:solidFill>
-              </a:rPr>
-              <a:t>10</a:t>
-            </a:r>
-          </a:p>
-        </p:txBody>
-      </p:sp>
-    </p:spTree>
-    <p:extLst>
-      <p:ext uri="{BB962C8B-B14F-4D97-AF65-F5344CB8AC3E}">
-        <p14:creationId xmlns:p14="http://schemas.microsoft.com/office/powerpoint/2010/main" val="1856479963"/>
       </p:ext>
     </p:extLst>
   </p:cSld>
@@ -3027,6 +2033,7 @@
           <a:lstStyle xmlns:a="http://schemas.openxmlformats.org/drawingml/2006/main"/>
           <a:p xmlns:a="http://schemas.openxmlformats.org/drawingml/2006/main">
             <a:pPr algn="l">
+              <a:buNone/>
               <a:defRPr sz="3075" b="1">
                 <a:solidFill>
                   <a:srgbClr val="E6EFEB"/>
@@ -3110,6 +2117,7 @@
           <a:lstStyle xmlns:a="http://schemas.openxmlformats.org/drawingml/2006/main"/>
           <a:p xmlns:a="http://schemas.openxmlformats.org/drawingml/2006/main">
             <a:pPr algn="l">
+              <a:buNone/>
               <a:defRPr sz="1875" b="0">
                 <a:solidFill>
                   <a:srgbClr val="8CA098"/>
@@ -3193,6 +2201,7 @@
           <a:lstStyle xmlns:a="http://schemas.openxmlformats.org/drawingml/2006/main"/>
           <a:p xmlns:a="http://schemas.openxmlformats.org/drawingml/2006/main">
             <a:pPr algn="l">
+              <a:buNone/>
               <a:defRPr sz="1650" b="0">
                 <a:solidFill>
                   <a:srgbClr val="E6EFEB"/>
@@ -3276,6 +2285,7 @@
           <a:lstStyle xmlns:a="http://schemas.openxmlformats.org/drawingml/2006/main"/>
           <a:p xmlns:a="http://schemas.openxmlformats.org/drawingml/2006/main">
             <a:pPr algn="l">
+              <a:buNone/>
               <a:defRPr sz="1650" b="0">
                 <a:solidFill>
                   <a:srgbClr val="E6EFEB"/>
@@ -3359,6 +2369,7 @@
           <a:lstStyle xmlns:a="http://schemas.openxmlformats.org/drawingml/2006/main"/>
           <a:p xmlns:a="http://schemas.openxmlformats.org/drawingml/2006/main">
             <a:pPr algn="l">
+              <a:buNone/>
               <a:defRPr sz="1650" b="0">
                 <a:solidFill>
                   <a:srgbClr val="E6EFEB"/>
@@ -3442,6 +2453,7 @@
           <a:lstStyle xmlns:a="http://schemas.openxmlformats.org/drawingml/2006/main"/>
           <a:p xmlns:a="http://schemas.openxmlformats.org/drawingml/2006/main">
             <a:pPr algn="l">
+              <a:buNone/>
               <a:defRPr sz="1650" b="0">
                 <a:solidFill>
                   <a:srgbClr val="E6EFEB"/>
@@ -3527,6 +2539,7 @@
           <a:lstStyle xmlns:a="http://schemas.openxmlformats.org/drawingml/2006/main"/>
           <a:p xmlns:a="http://schemas.openxmlformats.org/drawingml/2006/main">
             <a:pPr algn="l">
+              <a:buNone/>
               <a:defRPr sz="1800" b="1">
                 <a:solidFill>
                   <a:srgbClr val="34D399"/>
@@ -3577,6 +2590,7 @@
           <a:lstStyle xmlns:a="http://schemas.openxmlformats.org/drawingml/2006/main"/>
           <a:p xmlns:a="http://schemas.openxmlformats.org/drawingml/2006/main">
             <a:pPr algn="l">
+              <a:buNone/>
               <a:defRPr sz="1875" b="0">
                 <a:solidFill>
                   <a:srgbClr val="E6EFEB"/>
@@ -3627,6 +2641,7 @@
           <a:lstStyle xmlns:a="http://schemas.openxmlformats.org/drawingml/2006/main"/>
           <a:p xmlns:a="http://schemas.openxmlformats.org/drawingml/2006/main">
             <a:pPr algn="l">
+              <a:buNone/>
               <a:defRPr sz="1050" b="1">
                 <a:solidFill>
                   <a:srgbClr val="8CA098"/>
@@ -3677,6 +2692,7 @@
           <a:lstStyle xmlns:a="http://schemas.openxmlformats.org/drawingml/2006/main"/>
           <a:p xmlns:a="http://schemas.openxmlformats.org/drawingml/2006/main">
             <a:pPr algn="r">
+              <a:buNone/>
               <a:defRPr sz="1050" b="0">
                 <a:solidFill>
                   <a:srgbClr val="8CA098"/>
@@ -3756,6 +2772,7 @@
           <a:lstStyle xmlns:a="http://schemas.openxmlformats.org/drawingml/2006/main"/>
           <a:p xmlns:a="http://schemas.openxmlformats.org/drawingml/2006/main">
             <a:pPr algn="l">
+              <a:buNone/>
               <a:defRPr sz="3000" b="1">
                 <a:solidFill>
                   <a:srgbClr val="E6EFEB"/>
@@ -3806,6 +2823,7 @@
           <a:lstStyle xmlns:a="http://schemas.openxmlformats.org/drawingml/2006/main"/>
           <a:p xmlns:a="http://schemas.openxmlformats.org/drawingml/2006/main">
             <a:pPr algn="l">
+              <a:buNone/>
               <a:defRPr sz="1575" b="0">
                 <a:solidFill>
                   <a:srgbClr val="8CA098"/>
@@ -3825,14 +2843,14 @@
       </p:sp>
       <p:pic>
         <p:nvPicPr>
-          <p:cNvPr id="9" name=""/>
+          <p:cNvPr id="11" name=""/>
           <p:cNvPicPr>
             <a:picLocks xmlns:a="http://schemas.openxmlformats.org/drawingml/2006/main" noChangeAspect="1"/>
           </p:cNvPicPr>
           <p:nvPr/>
         </p:nvPicPr>
         <p:blipFill>
-          <a:blip xmlns:r="http://schemas.openxmlformats.org/officeDocument/2006/relationships" xmlns:a="http://schemas.openxmlformats.org/drawingml/2006/main" r:embed="Rf61c9c01e4d549a3"/>
+          <a:blip xmlns:r="http://schemas.openxmlformats.org/officeDocument/2006/relationships" xmlns:a="http://schemas.openxmlformats.org/drawingml/2006/main" r:embed="Rc0ae416044a24f52"/>
           <a:stretch xmlns:a="http://schemas.openxmlformats.org/drawingml/2006/main"/>
         </p:blipFill>
         <p:spPr>
@@ -3880,6 +2898,7 @@
           <a:lstStyle xmlns:a="http://schemas.openxmlformats.org/drawingml/2006/main"/>
           <a:p xmlns:a="http://schemas.openxmlformats.org/drawingml/2006/main">
             <a:pPr algn="l">
+              <a:buNone/>
               <a:defRPr sz="1650" b="1">
                 <a:solidFill>
                   <a:srgbClr val="34D399"/>
@@ -3930,6 +2949,7 @@
           <a:lstStyle xmlns:a="http://schemas.openxmlformats.org/drawingml/2006/main"/>
           <a:p xmlns:a="http://schemas.openxmlformats.org/drawingml/2006/main">
             <a:pPr algn="l">
+              <a:buNone/>
               <a:defRPr sz="1050" b="1">
                 <a:solidFill>
                   <a:srgbClr val="8CA098"/>
@@ -3980,6 +3000,7 @@
           <a:lstStyle xmlns:a="http://schemas.openxmlformats.org/drawingml/2006/main"/>
           <a:p xmlns:a="http://schemas.openxmlformats.org/drawingml/2006/main">
             <a:pPr algn="r">
+              <a:buNone/>
               <a:defRPr sz="1050" b="0">
                 <a:solidFill>
                   <a:srgbClr val="8CA098"/>
@@ -4059,6 +3080,7 @@
           <a:lstStyle xmlns:a="http://schemas.openxmlformats.org/drawingml/2006/main"/>
           <a:p xmlns:a="http://schemas.openxmlformats.org/drawingml/2006/main">
             <a:pPr algn="l">
+              <a:buNone/>
               <a:defRPr sz="2925" b="1">
                 <a:solidFill>
                   <a:srgbClr val="E6EFEB"/>
@@ -4109,6 +3131,7 @@
           <a:lstStyle xmlns:a="http://schemas.openxmlformats.org/drawingml/2006/main"/>
           <a:p xmlns:a="http://schemas.openxmlformats.org/drawingml/2006/main">
             <a:pPr algn="l">
+              <a:buNone/>
               <a:defRPr sz="1575" b="0">
                 <a:solidFill>
                   <a:srgbClr val="8CA098"/>
@@ -4128,14 +3151,14 @@
       </p:sp>
       <p:pic>
         <p:nvPicPr>
-          <p:cNvPr id="13" name=""/>
+          <p:cNvPr id="15" name=""/>
           <p:cNvPicPr>
             <a:picLocks xmlns:a="http://schemas.openxmlformats.org/drawingml/2006/main" noChangeAspect="1"/>
           </p:cNvPicPr>
           <p:nvPr/>
         </p:nvPicPr>
         <p:blipFill>
-          <a:blip xmlns:r="http://schemas.openxmlformats.org/officeDocument/2006/relationships" xmlns:a="http://schemas.openxmlformats.org/drawingml/2006/main" r:embed="R2e857ea350db4a72"/>
+          <a:blip xmlns:r="http://schemas.openxmlformats.org/officeDocument/2006/relationships" xmlns:a="http://schemas.openxmlformats.org/drawingml/2006/main" r:embed="R5bcb98c25e49495f"/>
           <a:stretch xmlns:a="http://schemas.openxmlformats.org/drawingml/2006/main"/>
         </p:blipFill>
         <p:spPr>
@@ -4218,6 +3241,7 @@
           <a:lstStyle xmlns:a="http://schemas.openxmlformats.org/drawingml/2006/main"/>
           <a:p xmlns:a="http://schemas.openxmlformats.org/drawingml/2006/main">
             <a:pPr algn="l">
+              <a:buNone/>
               <a:defRPr sz="1800" b="1">
                 <a:solidFill>
                   <a:srgbClr val="34D399"/>
@@ -4268,6 +3292,7 @@
           <a:lstStyle xmlns:a="http://schemas.openxmlformats.org/drawingml/2006/main"/>
           <a:p xmlns:a="http://schemas.openxmlformats.org/drawingml/2006/main">
             <a:pPr algn="l">
+              <a:buNone/>
               <a:defRPr sz="2850" b="1">
                 <a:solidFill>
                   <a:srgbClr val="E6EFEB"/>
@@ -4280,7 +3305,7 @@
                   <a:srgbClr val="E6EFEB"/>
                 </a:solidFill>
               </a:rPr>
-              <a:t>219-328ms</a:t>
+              <a:t>p50 328ms</a:t>
             </a:r>
           </a:p>
         </p:txBody>
@@ -4318,6 +3343,7 @@
           <a:lstStyle xmlns:a="http://schemas.openxmlformats.org/drawingml/2006/main"/>
           <a:p xmlns:a="http://schemas.openxmlformats.org/drawingml/2006/main">
             <a:pPr algn="l">
+              <a:buNone/>
               <a:defRPr sz="1350" b="0">
                 <a:solidFill>
                   <a:srgbClr val="8CA098"/>
@@ -4368,6 +3394,7 @@
           <a:lstStyle xmlns:a="http://schemas.openxmlformats.org/drawingml/2006/main"/>
           <a:p xmlns:a="http://schemas.openxmlformats.org/drawingml/2006/main">
             <a:pPr algn="l">
+              <a:buNone/>
               <a:defRPr sz="1800" b="1">
                 <a:solidFill>
                   <a:srgbClr val="E6EFEB"/>
@@ -4418,6 +3445,7 @@
           <a:lstStyle xmlns:a="http://schemas.openxmlformats.org/drawingml/2006/main"/>
           <a:p xmlns:a="http://schemas.openxmlformats.org/drawingml/2006/main">
             <a:pPr algn="l">
+              <a:buNone/>
               <a:defRPr sz="1050" b="1">
                 <a:solidFill>
                   <a:srgbClr val="8CA098"/>
@@ -4468,6 +3496,7 @@
           <a:lstStyle xmlns:a="http://schemas.openxmlformats.org/drawingml/2006/main"/>
           <a:p xmlns:a="http://schemas.openxmlformats.org/drawingml/2006/main">
             <a:pPr algn="r">
+              <a:buNone/>
               <a:defRPr sz="1050" b="0">
                 <a:solidFill>
                   <a:srgbClr val="8CA098"/>
@@ -4547,6 +3576,7 @@
           <a:lstStyle xmlns:a="http://schemas.openxmlformats.org/drawingml/2006/main"/>
           <a:p xmlns:a="http://schemas.openxmlformats.org/drawingml/2006/main">
             <a:pPr algn="l">
+              <a:buNone/>
               <a:defRPr sz="3000" b="1">
                 <a:solidFill>
                   <a:srgbClr val="E6EFEB"/>
@@ -4597,6 +3627,7 @@
           <a:lstStyle xmlns:a="http://schemas.openxmlformats.org/drawingml/2006/main"/>
           <a:p xmlns:a="http://schemas.openxmlformats.org/drawingml/2006/main">
             <a:pPr algn="l">
+              <a:buNone/>
               <a:defRPr sz="1650" b="0">
                 <a:solidFill>
                   <a:srgbClr val="8CA098"/>
@@ -4682,6 +3713,7 @@
           <a:lstStyle xmlns:a="http://schemas.openxmlformats.org/drawingml/2006/main"/>
           <a:p xmlns:a="http://schemas.openxmlformats.org/drawingml/2006/main">
             <a:pPr algn="l">
+              <a:buNone/>
               <a:defRPr sz="1800" b="1">
                 <a:solidFill>
                   <a:srgbClr val="34D399"/>
@@ -4732,6 +3764,7 @@
           <a:lstStyle xmlns:a="http://schemas.openxmlformats.org/drawingml/2006/main"/>
           <a:p xmlns:a="http://schemas.openxmlformats.org/drawingml/2006/main">
             <a:pPr algn="l">
+              <a:buNone/>
               <a:defRPr sz="1500" b="0">
                 <a:solidFill>
                   <a:srgbClr val="E6EFEB"/>
@@ -4817,6 +3850,7 @@
           <a:lstStyle xmlns:a="http://schemas.openxmlformats.org/drawingml/2006/main"/>
           <a:p xmlns:a="http://schemas.openxmlformats.org/drawingml/2006/main">
             <a:pPr algn="l">
+              <a:buNone/>
               <a:defRPr sz="1800" b="1">
                 <a:solidFill>
                   <a:srgbClr val="34D399"/>
@@ -4867,6 +3901,7 @@
           <a:lstStyle xmlns:a="http://schemas.openxmlformats.org/drawingml/2006/main"/>
           <a:p xmlns:a="http://schemas.openxmlformats.org/drawingml/2006/main">
             <a:pPr algn="l">
+              <a:buNone/>
               <a:defRPr sz="1500" b="0">
                 <a:solidFill>
                   <a:srgbClr val="E6EFEB"/>
@@ -4952,6 +3987,7 @@
           <a:lstStyle xmlns:a="http://schemas.openxmlformats.org/drawingml/2006/main"/>
           <a:p xmlns:a="http://schemas.openxmlformats.org/drawingml/2006/main">
             <a:pPr algn="l">
+              <a:buNone/>
               <a:defRPr sz="1800" b="1">
                 <a:solidFill>
                   <a:srgbClr val="34D399"/>
@@ -5002,6 +4038,7 @@
           <a:lstStyle xmlns:a="http://schemas.openxmlformats.org/drawingml/2006/main"/>
           <a:p xmlns:a="http://schemas.openxmlformats.org/drawingml/2006/main">
             <a:pPr algn="l">
+              <a:buNone/>
               <a:defRPr sz="1500" b="0">
                 <a:solidFill>
                   <a:srgbClr val="E6EFEB"/>
@@ -5087,6 +4124,7 @@
           <a:lstStyle xmlns:a="http://schemas.openxmlformats.org/drawingml/2006/main"/>
           <a:p xmlns:a="http://schemas.openxmlformats.org/drawingml/2006/main">
             <a:pPr algn="l">
+              <a:buNone/>
               <a:defRPr sz="1800" b="1">
                 <a:solidFill>
                   <a:srgbClr val="34D399"/>
@@ -5137,6 +4175,7 @@
           <a:lstStyle xmlns:a="http://schemas.openxmlformats.org/drawingml/2006/main"/>
           <a:p xmlns:a="http://schemas.openxmlformats.org/drawingml/2006/main">
             <a:pPr algn="l">
+              <a:buNone/>
               <a:defRPr sz="1500" b="0">
                 <a:solidFill>
                   <a:srgbClr val="E6EFEB"/>
@@ -5220,6 +4259,7 @@
           <a:lstStyle xmlns:a="http://schemas.openxmlformats.org/drawingml/2006/main"/>
           <a:p xmlns:a="http://schemas.openxmlformats.org/drawingml/2006/main">
             <a:pPr algn="l">
+              <a:buNone/>
               <a:defRPr sz="1500" b="0">
                 <a:solidFill>
                   <a:srgbClr val="E6EFEB"/>
@@ -5303,6 +4343,7 @@
           <a:lstStyle xmlns:a="http://schemas.openxmlformats.org/drawingml/2006/main"/>
           <a:p xmlns:a="http://schemas.openxmlformats.org/drawingml/2006/main">
             <a:pPr algn="l">
+              <a:buNone/>
               <a:defRPr sz="1500" b="0">
                 <a:solidFill>
                   <a:srgbClr val="E6EFEB"/>
@@ -5386,6 +4427,7 @@
           <a:lstStyle xmlns:a="http://schemas.openxmlformats.org/drawingml/2006/main"/>
           <a:p xmlns:a="http://schemas.openxmlformats.org/drawingml/2006/main">
             <a:pPr algn="l">
+              <a:buNone/>
               <a:defRPr sz="1500" b="0">
                 <a:solidFill>
                   <a:srgbClr val="E6EFEB"/>
@@ -5436,6 +4478,7 @@
           <a:lstStyle xmlns:a="http://schemas.openxmlformats.org/drawingml/2006/main"/>
           <a:p xmlns:a="http://schemas.openxmlformats.org/drawingml/2006/main">
             <a:pPr algn="l">
+              <a:buNone/>
               <a:defRPr sz="1050" b="1">
                 <a:solidFill>
                   <a:srgbClr val="8CA098"/>
@@ -5486,6 +4529,7 @@
           <a:lstStyle xmlns:a="http://schemas.openxmlformats.org/drawingml/2006/main"/>
           <a:p xmlns:a="http://schemas.openxmlformats.org/drawingml/2006/main">
             <a:pPr algn="r">
+              <a:buNone/>
               <a:defRPr sz="1050" b="0">
                 <a:solidFill>
                   <a:srgbClr val="8CA098"/>
@@ -5565,6 +4609,7 @@
           <a:lstStyle xmlns:a="http://schemas.openxmlformats.org/drawingml/2006/main"/>
           <a:p xmlns:a="http://schemas.openxmlformats.org/drawingml/2006/main">
             <a:pPr algn="l">
+              <a:buNone/>
               <a:defRPr sz="2925" b="1">
                 <a:solidFill>
                   <a:srgbClr val="E6EFEB"/>
@@ -5615,6 +4660,7 @@
           <a:lstStyle xmlns:a="http://schemas.openxmlformats.org/drawingml/2006/main"/>
           <a:p xmlns:a="http://schemas.openxmlformats.org/drawingml/2006/main">
             <a:pPr algn="l">
+              <a:buNone/>
               <a:defRPr sz="1575" b="0">
                 <a:solidFill>
                   <a:srgbClr val="8CA098"/>
@@ -5700,6 +4746,7 @@
           <a:lstStyle xmlns:a="http://schemas.openxmlformats.org/drawingml/2006/main"/>
           <a:p xmlns:a="http://schemas.openxmlformats.org/drawingml/2006/main">
             <a:pPr algn="l">
+              <a:buNone/>
               <a:defRPr sz="2100" b="1">
                 <a:solidFill>
                   <a:srgbClr val="34D399"/>
@@ -5750,6 +4797,7 @@
           <a:lstStyle xmlns:a="http://schemas.openxmlformats.org/drawingml/2006/main"/>
           <a:p xmlns:a="http://schemas.openxmlformats.org/drawingml/2006/main">
             <a:pPr algn="l">
+              <a:buNone/>
               <a:defRPr sz="3900" b="1">
                 <a:solidFill>
                   <a:srgbClr val="E6EFEB"/>
@@ -5800,6 +4848,7 @@
           <a:lstStyle xmlns:a="http://schemas.openxmlformats.org/drawingml/2006/main"/>
           <a:p xmlns:a="http://schemas.openxmlformats.org/drawingml/2006/main">
             <a:pPr algn="l">
+              <a:buNone/>
               <a:defRPr sz="1575" b="0">
                 <a:solidFill>
                   <a:srgbClr val="8CA098"/>
@@ -5885,6 +4934,7 @@
           <a:lstStyle xmlns:a="http://schemas.openxmlformats.org/drawingml/2006/main"/>
           <a:p xmlns:a="http://schemas.openxmlformats.org/drawingml/2006/main">
             <a:pPr algn="l">
+              <a:buNone/>
               <a:defRPr sz="2100" b="1">
                 <a:solidFill>
                   <a:srgbClr val="34D399"/>
@@ -5935,6 +4985,7 @@
           <a:lstStyle xmlns:a="http://schemas.openxmlformats.org/drawingml/2006/main"/>
           <a:p xmlns:a="http://schemas.openxmlformats.org/drawingml/2006/main">
             <a:pPr algn="l">
+              <a:buNone/>
               <a:defRPr sz="3900" b="1">
                 <a:solidFill>
                   <a:srgbClr val="E6EFEB"/>
@@ -5985,6 +5036,7 @@
           <a:lstStyle xmlns:a="http://schemas.openxmlformats.org/drawingml/2006/main"/>
           <a:p xmlns:a="http://schemas.openxmlformats.org/drawingml/2006/main">
             <a:pPr algn="l">
+              <a:buNone/>
               <a:defRPr sz="1575" b="0">
                 <a:solidFill>
                   <a:srgbClr val="8CA098"/>
@@ -6035,6 +5087,7 @@
           <a:lstStyle xmlns:a="http://schemas.openxmlformats.org/drawingml/2006/main"/>
           <a:p xmlns:a="http://schemas.openxmlformats.org/drawingml/2006/main">
             <a:pPr algn="l">
+              <a:buNone/>
               <a:defRPr sz="1800" b="0">
                 <a:solidFill>
                   <a:srgbClr val="E6EFEB"/>
@@ -6085,6 +5138,7 @@
           <a:lstStyle xmlns:a="http://schemas.openxmlformats.org/drawingml/2006/main"/>
           <a:p xmlns:a="http://schemas.openxmlformats.org/drawingml/2006/main">
             <a:pPr algn="l">
+              <a:buNone/>
               <a:defRPr sz="1050" b="1">
                 <a:solidFill>
                   <a:srgbClr val="8CA098"/>
@@ -6135,6 +5189,7 @@
           <a:lstStyle xmlns:a="http://schemas.openxmlformats.org/drawingml/2006/main"/>
           <a:p xmlns:a="http://schemas.openxmlformats.org/drawingml/2006/main">
             <a:pPr algn="r">
+              <a:buNone/>
               <a:defRPr sz="1050" b="0">
                 <a:solidFill>
                   <a:srgbClr val="8CA098"/>
@@ -6214,6 +5269,7 @@
           <a:lstStyle xmlns:a="http://schemas.openxmlformats.org/drawingml/2006/main"/>
           <a:p xmlns:a="http://schemas.openxmlformats.org/drawingml/2006/main">
             <a:pPr algn="l">
+              <a:buNone/>
               <a:defRPr sz="2850" b="1">
                 <a:solidFill>
                   <a:srgbClr val="E6EFEB"/>
@@ -6264,6 +5320,7 @@
           <a:lstStyle xmlns:a="http://schemas.openxmlformats.org/drawingml/2006/main"/>
           <a:p xmlns:a="http://schemas.openxmlformats.org/drawingml/2006/main">
             <a:pPr algn="l">
+              <a:buNone/>
               <a:defRPr sz="1575" b="0">
                 <a:solidFill>
                   <a:srgbClr val="8CA098"/>
@@ -6283,14 +5340,14 @@
       </p:sp>
       <p:pic>
         <p:nvPicPr>
-          <p:cNvPr id="18" name=""/>
+          <p:cNvPr id="20" name=""/>
           <p:cNvPicPr>
             <a:picLocks xmlns:a="http://schemas.openxmlformats.org/drawingml/2006/main" noChangeAspect="1"/>
           </p:cNvPicPr>
           <p:nvPr/>
         </p:nvPicPr>
         <p:blipFill>
-          <a:blip xmlns:r="http://schemas.openxmlformats.org/officeDocument/2006/relationships" xmlns:a="http://schemas.openxmlformats.org/drawingml/2006/main" r:embed="R9f504ae1fdf84c96"/>
+          <a:blip xmlns:r="http://schemas.openxmlformats.org/officeDocument/2006/relationships" xmlns:a="http://schemas.openxmlformats.org/drawingml/2006/main" r:embed="Rf152cff4ee6a43aa"/>
           <a:stretch xmlns:a="http://schemas.openxmlformats.org/drawingml/2006/main"/>
         </p:blipFill>
         <p:spPr>
@@ -6373,6 +5430,7 @@
           <a:lstStyle xmlns:a="http://schemas.openxmlformats.org/drawingml/2006/main"/>
           <a:p xmlns:a="http://schemas.openxmlformats.org/drawingml/2006/main">
             <a:pPr algn="l">
+              <a:buNone/>
               <a:defRPr sz="1575" b="1">
                 <a:solidFill>
                   <a:srgbClr val="34D399"/>
@@ -6423,6 +5481,7 @@
           <a:lstStyle xmlns:a="http://schemas.openxmlformats.org/drawingml/2006/main"/>
           <a:p xmlns:a="http://schemas.openxmlformats.org/drawingml/2006/main">
             <a:pPr algn="l">
+              <a:buNone/>
               <a:defRPr sz="3600" b="1">
                 <a:solidFill>
                   <a:srgbClr val="E6EFEB"/>
@@ -6435,7 +5494,7 @@
                   <a:srgbClr val="E6EFEB"/>
                 </a:solidFill>
               </a:rPr>
-              <a:t>26 / 33</a:t>
+              <a:t>25 / 33</a:t>
             </a:r>
           </a:p>
         </p:txBody>
@@ -6473,6 +5532,7 @@
           <a:lstStyle xmlns:a="http://schemas.openxmlformats.org/drawingml/2006/main"/>
           <a:p xmlns:a="http://schemas.openxmlformats.org/drawingml/2006/main">
             <a:pPr algn="l">
+              <a:buNone/>
               <a:defRPr sz="1350" b="0">
                 <a:solidFill>
                   <a:srgbClr val="8CA098"/>
@@ -6556,6 +5616,7 @@
           <a:lstStyle xmlns:a="http://schemas.openxmlformats.org/drawingml/2006/main"/>
           <a:p xmlns:a="http://schemas.openxmlformats.org/drawingml/2006/main">
             <a:pPr algn="l">
+              <a:buNone/>
               <a:defRPr sz="1500" b="0">
                 <a:solidFill>
                   <a:srgbClr val="E6EFEB"/>
@@ -6639,6 +5700,7 @@
           <a:lstStyle xmlns:a="http://schemas.openxmlformats.org/drawingml/2006/main"/>
           <a:p xmlns:a="http://schemas.openxmlformats.org/drawingml/2006/main">
             <a:pPr algn="l">
+              <a:buNone/>
               <a:defRPr sz="1500" b="0">
                 <a:solidFill>
                   <a:srgbClr val="E6EFEB"/>
@@ -6722,6 +5784,7 @@
           <a:lstStyle xmlns:a="http://schemas.openxmlformats.org/drawingml/2006/main"/>
           <a:p xmlns:a="http://schemas.openxmlformats.org/drawingml/2006/main">
             <a:pPr algn="l">
+              <a:buNone/>
               <a:defRPr sz="1500" b="0">
                 <a:solidFill>
                   <a:srgbClr val="E6EFEB"/>
@@ -6772,6 +5835,7 @@
           <a:lstStyle xmlns:a="http://schemas.openxmlformats.org/drawingml/2006/main"/>
           <a:p xmlns:a="http://schemas.openxmlformats.org/drawingml/2006/main">
             <a:pPr algn="l">
+              <a:buNone/>
               <a:defRPr sz="1050" b="1">
                 <a:solidFill>
                   <a:srgbClr val="8CA098"/>
@@ -6822,6 +5886,7 @@
           <a:lstStyle xmlns:a="http://schemas.openxmlformats.org/drawingml/2006/main"/>
           <a:p xmlns:a="http://schemas.openxmlformats.org/drawingml/2006/main">
             <a:pPr algn="r">
+              <a:buNone/>
               <a:defRPr sz="1050" b="0">
                 <a:solidFill>
                   <a:srgbClr val="8CA098"/>
@@ -6901,6 +5966,7 @@
           <a:lstStyle xmlns:a="http://schemas.openxmlformats.org/drawingml/2006/main"/>
           <a:p xmlns:a="http://schemas.openxmlformats.org/drawingml/2006/main">
             <a:pPr algn="l">
+              <a:buNone/>
               <a:defRPr sz="2775" b="1">
                 <a:solidFill>
                   <a:srgbClr val="E6EFEB"/>
@@ -6920,14 +5986,14 @@
       </p:sp>
       <p:pic>
         <p:nvPicPr>
-          <p:cNvPr id="14" name=""/>
+          <p:cNvPr id="17" name=""/>
           <p:cNvPicPr>
             <a:picLocks xmlns:a="http://schemas.openxmlformats.org/drawingml/2006/main" noChangeAspect="1"/>
           </p:cNvPicPr>
           <p:nvPr/>
         </p:nvPicPr>
         <p:blipFill>
-          <a:blip xmlns:r="http://schemas.openxmlformats.org/officeDocument/2006/relationships" xmlns:a="http://schemas.openxmlformats.org/drawingml/2006/main" r:embed="R59303b7742024522"/>
+          <a:blip xmlns:r="http://schemas.openxmlformats.org/officeDocument/2006/relationships" xmlns:a="http://schemas.openxmlformats.org/drawingml/2006/main" r:embed="R89f40af0cb1148ba"/>
           <a:stretch xmlns:a="http://schemas.openxmlformats.org/drawingml/2006/main"/>
         </p:blipFill>
         <p:spPr>
@@ -6944,14 +6010,14 @@
       </p:pic>
       <p:pic>
         <p:nvPicPr>
-          <p:cNvPr id="15" name=""/>
+          <p:cNvPr id="18" name=""/>
           <p:cNvPicPr>
             <a:picLocks xmlns:a="http://schemas.openxmlformats.org/drawingml/2006/main" noChangeAspect="1"/>
           </p:cNvPicPr>
           <p:nvPr/>
         </p:nvPicPr>
         <p:blipFill>
-          <a:blip xmlns:r="http://schemas.openxmlformats.org/officeDocument/2006/relationships" xmlns:a="http://schemas.openxmlformats.org/drawingml/2006/main" r:embed="R83690ae99a1c425f"/>
+          <a:blip xmlns:r="http://schemas.openxmlformats.org/officeDocument/2006/relationships" xmlns:a="http://schemas.openxmlformats.org/drawingml/2006/main" r:embed="R670fb9b2527d426f"/>
           <a:stretch xmlns:a="http://schemas.openxmlformats.org/drawingml/2006/main"/>
         </p:blipFill>
         <p:spPr>
@@ -7032,6 +6098,7 @@
           <a:lstStyle xmlns:a="http://schemas.openxmlformats.org/drawingml/2006/main"/>
           <a:p xmlns:a="http://schemas.openxmlformats.org/drawingml/2006/main">
             <a:pPr algn="l">
+              <a:buNone/>
               <a:defRPr sz="1500" b="0">
                 <a:solidFill>
                   <a:srgbClr val="E6EFEB"/>
@@ -7115,6 +6182,7 @@
           <a:lstStyle xmlns:a="http://schemas.openxmlformats.org/drawingml/2006/main"/>
           <a:p xmlns:a="http://schemas.openxmlformats.org/drawingml/2006/main">
             <a:pPr algn="l">
+              <a:buNone/>
               <a:defRPr sz="1500" b="0">
                 <a:solidFill>
                   <a:srgbClr val="E6EFEB"/>
@@ -7198,6 +6266,7 @@
           <a:lstStyle xmlns:a="http://schemas.openxmlformats.org/drawingml/2006/main"/>
           <a:p xmlns:a="http://schemas.openxmlformats.org/drawingml/2006/main">
             <a:pPr algn="l">
+              <a:buNone/>
               <a:defRPr sz="1500" b="0">
                 <a:solidFill>
                   <a:srgbClr val="E6EFEB"/>
@@ -7248,6 +6317,7 @@
           <a:lstStyle xmlns:a="http://schemas.openxmlformats.org/drawingml/2006/main"/>
           <a:p xmlns:a="http://schemas.openxmlformats.org/drawingml/2006/main">
             <a:pPr algn="l">
+              <a:buNone/>
               <a:defRPr sz="1800" b="1">
                 <a:solidFill>
                   <a:srgbClr val="34D399"/>
@@ -7298,6 +6368,7 @@
           <a:lstStyle xmlns:a="http://schemas.openxmlformats.org/drawingml/2006/main"/>
           <a:p xmlns:a="http://schemas.openxmlformats.org/drawingml/2006/main">
             <a:pPr algn="l">
+              <a:buNone/>
               <a:defRPr sz="1050" b="1">
                 <a:solidFill>
                   <a:srgbClr val="8CA098"/>
@@ -7348,6 +6419,7 @@
           <a:lstStyle xmlns:a="http://schemas.openxmlformats.org/drawingml/2006/main"/>
           <a:p xmlns:a="http://schemas.openxmlformats.org/drawingml/2006/main">
             <a:pPr algn="r">
+              <a:buNone/>
               <a:defRPr sz="1050" b="0">
                 <a:solidFill>
                   <a:srgbClr val="8CA098"/>
@@ -7369,925 +6441,6 @@
     <p:extLst>
       <p:ext uri="{BB962C8B-B14F-4D97-AF65-F5344CB8AC3E}">
         <p14:creationId xmlns:p14="http://schemas.microsoft.com/office/powerpoint/2010/main" val="1143506241"/>
-      </p:ext>
-    </p:extLst>
-  </p:cSld>
-</p:sld>
-</file>
-
-<file path=ppt/slides/slide9.xml><?xml version="1.0" encoding="utf-8"?>
-<p:sld xmlns:p="http://schemas.openxmlformats.org/presentationml/2006/main">
-  <p:cSld>
-    <p:bg>
-      <p:bgPr>
-        <a:solidFill xmlns:a="http://schemas.openxmlformats.org/drawingml/2006/main">
-          <a:srgbClr val="0B0F0E"/>
-        </a:solidFill>
-      </p:bgPr>
-    </p:bg>
-    <p:spTree>
-      <p:nvGrpSpPr>
-        <p:cNvPr id="1" name=""/>
-        <p:cNvGrpSpPr/>
-        <p:nvPr/>
-      </p:nvGrpSpPr>
-      <p:grpSpPr>
-        <a:xfrm xmlns:a="http://schemas.openxmlformats.org/drawingml/2006/main"/>
-      </p:grpSpPr>
-      <p:sp>
-        <p:nvSpPr>
-          <p:cNvPr id="20" name="">
-            <a:extLst xmlns:a="http://schemas.openxmlformats.org/drawingml/2006/main">
-              <a:ext uri="{FF2B5EF4-FFF2-40B4-BE49-F238E27FC236}">
-                <a16:creationId xmlns:a16="http://schemas.microsoft.com/office/drawing/2014/main" id="{84305FF1-72B1-4432-8296-4CBBB35A8417}"/>
-              </a:ext>
-            </a:extLst>
-          </p:cNvPr>
-          <p:cNvSpPr>
-            <a:spLocks xmlns:a="http://schemas.openxmlformats.org/drawingml/2006/main" noGrp="1"/>
-          </p:cNvSpPr>
-          <p:nvPr/>
-        </p:nvSpPr>
-        <p:spPr>
-          <a:xfrm xmlns:a="http://schemas.openxmlformats.org/drawingml/2006/main">
-            <a:off x="685800" y="533400"/>
-            <a:ext cx="8953500" cy="514350"/>
-          </a:xfrm>
-          <a:prstGeom xmlns:a="http://schemas.openxmlformats.org/drawingml/2006/main" prst="rect">
-            <a:avLst/>
-          </a:prstGeom>
-          <a:noFill xmlns:a="http://schemas.openxmlformats.org/drawingml/2006/main"/>
-          <a:ln xmlns:a="http://schemas.openxmlformats.org/drawingml/2006/main" w="0">
-            <a:noFill/>
-            <a:prstDash val="solid"/>
-          </a:ln>
-        </p:spPr>
-        <p:txBody>
-          <a:bodyPr xmlns:a="http://schemas.openxmlformats.org/drawingml/2006/main"/>
-          <a:lstStyle xmlns:a="http://schemas.openxmlformats.org/drawingml/2006/main"/>
-          <a:p xmlns:a="http://schemas.openxmlformats.org/drawingml/2006/main">
-            <a:pPr algn="l">
-              <a:defRPr sz="3000" b="1">
-                <a:solidFill>
-                  <a:srgbClr val="E6EFEB"/>
-                </a:solidFill>
-              </a:defRPr>
-            </a:pPr>
-            <a:r>
-              <a:rPr sz="3000" b="1">
-                <a:solidFill>
-                  <a:srgbClr val="E6EFEB"/>
-                </a:solidFill>
-              </a:rPr>
-              <a:t>The video should prove three behaviours quickly</a:t>
-            </a:r>
-          </a:p>
-        </p:txBody>
-      </p:sp>
-      <p:sp>
-        <p:nvSpPr>
-          <p:cNvPr id="2" name="">
-            <a:extLst xmlns:a="http://schemas.openxmlformats.org/drawingml/2006/main">
-              <a:ext uri="{FF2B5EF4-FFF2-40B4-BE49-F238E27FC236}">
-                <a16:creationId xmlns:a16="http://schemas.microsoft.com/office/drawing/2014/main" id="{AEB815B2-E1A5-4B51-8059-728CAB33F87E}"/>
-              </a:ext>
-            </a:extLst>
-          </p:cNvPr>
-          <p:cNvSpPr>
-            <a:spLocks xmlns:a="http://schemas.openxmlformats.org/drawingml/2006/main" noGrp="1"/>
-          </p:cNvSpPr>
-          <p:nvPr/>
-        </p:nvSpPr>
-        <p:spPr>
-          <a:xfrm xmlns:a="http://schemas.openxmlformats.org/drawingml/2006/main">
-            <a:off x="990600" y="1466850"/>
-            <a:ext cx="9429750" cy="876300"/>
-          </a:xfrm>
-          <a:prstGeom xmlns:a="http://schemas.openxmlformats.org/drawingml/2006/main" prst="roundRect">
-            <a:avLst>
-              <a:gd name="adj" fmla="val 8696"/>
-            </a:avLst>
-          </a:prstGeom>
-          <a:solidFill xmlns:a="http://schemas.openxmlformats.org/drawingml/2006/main">
-            <a:srgbClr val="111614"/>
-          </a:solidFill>
-          <a:ln xmlns:a="http://schemas.openxmlformats.org/drawingml/2006/main" w="9525">
-            <a:solidFill>
-              <a:srgbClr val="26322F"/>
-            </a:solidFill>
-            <a:prstDash val="solid"/>
-          </a:ln>
-        </p:spPr>
-      </p:sp>
-      <p:sp>
-        <p:nvSpPr>
-          <p:cNvPr id="3" name="">
-            <a:extLst xmlns:a="http://schemas.openxmlformats.org/drawingml/2006/main">
-              <a:ext uri="{FF2B5EF4-FFF2-40B4-BE49-F238E27FC236}">
-                <a16:creationId xmlns:a16="http://schemas.microsoft.com/office/drawing/2014/main" id="{876C9E2C-6C77-4650-BF97-6E4502C19F07}"/>
-              </a:ext>
-            </a:extLst>
-          </p:cNvPr>
-          <p:cNvSpPr>
-            <a:spLocks xmlns:a="http://schemas.openxmlformats.org/drawingml/2006/main" noGrp="1"/>
-          </p:cNvSpPr>
-          <p:nvPr/>
-        </p:nvSpPr>
-        <p:spPr>
-          <a:xfrm xmlns:a="http://schemas.openxmlformats.org/drawingml/2006/main">
-            <a:off x="1257300" y="1638300"/>
-            <a:ext cx="476250" cy="438150"/>
-          </a:xfrm>
-          <a:prstGeom xmlns:a="http://schemas.openxmlformats.org/drawingml/2006/main" prst="rect">
-            <a:avLst/>
-          </a:prstGeom>
-          <a:noFill xmlns:a="http://schemas.openxmlformats.org/drawingml/2006/main"/>
-          <a:ln xmlns:a="http://schemas.openxmlformats.org/drawingml/2006/main" w="0">
-            <a:noFill/>
-            <a:prstDash val="solid"/>
-          </a:ln>
-        </p:spPr>
-        <p:txBody>
-          <a:bodyPr xmlns:a="http://schemas.openxmlformats.org/drawingml/2006/main"/>
-          <a:lstStyle xmlns:a="http://schemas.openxmlformats.org/drawingml/2006/main"/>
-          <a:p xmlns:a="http://schemas.openxmlformats.org/drawingml/2006/main">
-            <a:pPr algn="l">
-              <a:defRPr sz="2850" b="1">
-                <a:solidFill>
-                  <a:srgbClr val="34D399"/>
-                </a:solidFill>
-              </a:defRPr>
-            </a:pPr>
-            <a:r>
-              <a:rPr sz="2850" b="1">
-                <a:solidFill>
-                  <a:srgbClr val="34D399"/>
-                </a:solidFill>
-              </a:rPr>
-              <a:t>1</a:t>
-            </a:r>
-          </a:p>
-        </p:txBody>
-      </p:sp>
-      <p:sp>
-        <p:nvSpPr>
-          <p:cNvPr id="4" name="">
-            <a:extLst xmlns:a="http://schemas.openxmlformats.org/drawingml/2006/main">
-              <a:ext uri="{FF2B5EF4-FFF2-40B4-BE49-F238E27FC236}">
-                <a16:creationId xmlns:a16="http://schemas.microsoft.com/office/drawing/2014/main" id="{1923342F-CC67-4844-BE59-2D7783E73170}"/>
-              </a:ext>
-            </a:extLst>
-          </p:cNvPr>
-          <p:cNvSpPr>
-            <a:spLocks xmlns:a="http://schemas.openxmlformats.org/drawingml/2006/main" noGrp="1"/>
-          </p:cNvSpPr>
-          <p:nvPr/>
-        </p:nvSpPr>
-        <p:spPr>
-          <a:xfrm xmlns:a="http://schemas.openxmlformats.org/drawingml/2006/main">
-            <a:off x="2038350" y="1638300"/>
-            <a:ext cx="2476500" cy="285750"/>
-          </a:xfrm>
-          <a:prstGeom xmlns:a="http://schemas.openxmlformats.org/drawingml/2006/main" prst="rect">
-            <a:avLst/>
-          </a:prstGeom>
-          <a:noFill xmlns:a="http://schemas.openxmlformats.org/drawingml/2006/main"/>
-          <a:ln xmlns:a="http://schemas.openxmlformats.org/drawingml/2006/main" w="0">
-            <a:noFill/>
-            <a:prstDash val="solid"/>
-          </a:ln>
-        </p:spPr>
-        <p:txBody>
-          <a:bodyPr xmlns:a="http://schemas.openxmlformats.org/drawingml/2006/main"/>
-          <a:lstStyle xmlns:a="http://schemas.openxmlformats.org/drawingml/2006/main"/>
-          <a:p xmlns:a="http://schemas.openxmlformats.org/drawingml/2006/main">
-            <a:pPr algn="l">
-              <a:defRPr sz="1800" b="1">
-                <a:solidFill>
-                  <a:srgbClr val="E6EFEB"/>
-                </a:solidFill>
-              </a:defRPr>
-            </a:pPr>
-            <a:r>
-              <a:rPr sz="1800" b="1">
-                <a:solidFill>
-                  <a:srgbClr val="E6EFEB"/>
-                </a:solidFill>
-              </a:rPr>
-              <a:t>Normal call</a:t>
-            </a:r>
-          </a:p>
-        </p:txBody>
-      </p:sp>
-      <p:sp>
-        <p:nvSpPr>
-          <p:cNvPr id="5" name="">
-            <a:extLst xmlns:a="http://schemas.openxmlformats.org/drawingml/2006/main">
-              <a:ext uri="{FF2B5EF4-FFF2-40B4-BE49-F238E27FC236}">
-                <a16:creationId xmlns:a16="http://schemas.microsoft.com/office/drawing/2014/main" id="{EA7C4B44-C098-413D-B117-F73AC320D83A}"/>
-              </a:ext>
-            </a:extLst>
-          </p:cNvPr>
-          <p:cNvSpPr>
-            <a:spLocks xmlns:a="http://schemas.openxmlformats.org/drawingml/2006/main" noGrp="1"/>
-          </p:cNvSpPr>
-          <p:nvPr/>
-        </p:nvSpPr>
-        <p:spPr>
-          <a:xfrm xmlns:a="http://schemas.openxmlformats.org/drawingml/2006/main">
-            <a:off x="2038350" y="1981200"/>
-            <a:ext cx="7429500" cy="228600"/>
-          </a:xfrm>
-          <a:prstGeom xmlns:a="http://schemas.openxmlformats.org/drawingml/2006/main" prst="rect">
-            <a:avLst/>
-          </a:prstGeom>
-          <a:noFill xmlns:a="http://schemas.openxmlformats.org/drawingml/2006/main"/>
-          <a:ln xmlns:a="http://schemas.openxmlformats.org/drawingml/2006/main" w="0">
-            <a:noFill/>
-            <a:prstDash val="solid"/>
-          </a:ln>
-        </p:spPr>
-        <p:txBody>
-          <a:bodyPr xmlns:a="http://schemas.openxmlformats.org/drawingml/2006/main"/>
-          <a:lstStyle xmlns:a="http://schemas.openxmlformats.org/drawingml/2006/main"/>
-          <a:p xmlns:a="http://schemas.openxmlformats.org/drawingml/2006/main">
-            <a:pPr algn="l">
-              <a:defRPr sz="1350" b="0">
-                <a:solidFill>
-                  <a:srgbClr val="8CA098"/>
-                </a:solidFill>
-              </a:defRPr>
-            </a:pPr>
-            <a:r>
-              <a:rPr sz="1350" b="0">
-                <a:solidFill>
-                  <a:srgbClr val="8CA098"/>
-                </a:solidFill>
-              </a:rPr>
-              <a:t>Ask which accounts are slipping; show tool calls and grounded numbers.</a:t>
-            </a:r>
-          </a:p>
-        </p:txBody>
-      </p:sp>
-      <p:sp>
-        <p:nvSpPr>
-          <p:cNvPr id="6" name="">
-            <a:extLst xmlns:a="http://schemas.openxmlformats.org/drawingml/2006/main">
-              <a:ext uri="{FF2B5EF4-FFF2-40B4-BE49-F238E27FC236}">
-                <a16:creationId xmlns:a16="http://schemas.microsoft.com/office/drawing/2014/main" id="{753BE3EC-1BF4-4C93-8E1E-2420CE9F37DB}"/>
-              </a:ext>
-            </a:extLst>
-          </p:cNvPr>
-          <p:cNvSpPr>
-            <a:spLocks xmlns:a="http://schemas.openxmlformats.org/drawingml/2006/main" noGrp="1"/>
-          </p:cNvSpPr>
-          <p:nvPr/>
-        </p:nvSpPr>
-        <p:spPr>
-          <a:xfrm xmlns:a="http://schemas.openxmlformats.org/drawingml/2006/main">
-            <a:off x="990600" y="2495550"/>
-            <a:ext cx="9429750" cy="876300"/>
-          </a:xfrm>
-          <a:prstGeom xmlns:a="http://schemas.openxmlformats.org/drawingml/2006/main" prst="roundRect">
-            <a:avLst>
-              <a:gd name="adj" fmla="val 8696"/>
-            </a:avLst>
-          </a:prstGeom>
-          <a:solidFill xmlns:a="http://schemas.openxmlformats.org/drawingml/2006/main">
-            <a:srgbClr val="16201D"/>
-          </a:solidFill>
-          <a:ln xmlns:a="http://schemas.openxmlformats.org/drawingml/2006/main" w="9525">
-            <a:solidFill>
-              <a:srgbClr val="26322F"/>
-            </a:solidFill>
-            <a:prstDash val="solid"/>
-          </a:ln>
-        </p:spPr>
-      </p:sp>
-      <p:sp>
-        <p:nvSpPr>
-          <p:cNvPr id="7" name="">
-            <a:extLst xmlns:a="http://schemas.openxmlformats.org/drawingml/2006/main">
-              <a:ext uri="{FF2B5EF4-FFF2-40B4-BE49-F238E27FC236}">
-                <a16:creationId xmlns:a16="http://schemas.microsoft.com/office/drawing/2014/main" id="{650D1DBD-86CA-4B6D-AB13-A0DB1FD17A51}"/>
-              </a:ext>
-            </a:extLst>
-          </p:cNvPr>
-          <p:cNvSpPr>
-            <a:spLocks xmlns:a="http://schemas.openxmlformats.org/drawingml/2006/main" noGrp="1"/>
-          </p:cNvSpPr>
-          <p:nvPr/>
-        </p:nvSpPr>
-        <p:spPr>
-          <a:xfrm xmlns:a="http://schemas.openxmlformats.org/drawingml/2006/main">
-            <a:off x="1257300" y="2667000"/>
-            <a:ext cx="476250" cy="438150"/>
-          </a:xfrm>
-          <a:prstGeom xmlns:a="http://schemas.openxmlformats.org/drawingml/2006/main" prst="rect">
-            <a:avLst/>
-          </a:prstGeom>
-          <a:noFill xmlns:a="http://schemas.openxmlformats.org/drawingml/2006/main"/>
-          <a:ln xmlns:a="http://schemas.openxmlformats.org/drawingml/2006/main" w="0">
-            <a:noFill/>
-            <a:prstDash val="solid"/>
-          </a:ln>
-        </p:spPr>
-        <p:txBody>
-          <a:bodyPr xmlns:a="http://schemas.openxmlformats.org/drawingml/2006/main"/>
-          <a:lstStyle xmlns:a="http://schemas.openxmlformats.org/drawingml/2006/main"/>
-          <a:p xmlns:a="http://schemas.openxmlformats.org/drawingml/2006/main">
-            <a:pPr algn="l">
-              <a:defRPr sz="2850" b="1">
-                <a:solidFill>
-                  <a:srgbClr val="34D399"/>
-                </a:solidFill>
-              </a:defRPr>
-            </a:pPr>
-            <a:r>
-              <a:rPr sz="2850" b="1">
-                <a:solidFill>
-                  <a:srgbClr val="34D399"/>
-                </a:solidFill>
-              </a:rPr>
-              <a:t>2</a:t>
-            </a:r>
-          </a:p>
-        </p:txBody>
-      </p:sp>
-      <p:sp>
-        <p:nvSpPr>
-          <p:cNvPr id="8" name="">
-            <a:extLst xmlns:a="http://schemas.openxmlformats.org/drawingml/2006/main">
-              <a:ext uri="{FF2B5EF4-FFF2-40B4-BE49-F238E27FC236}">
-                <a16:creationId xmlns:a16="http://schemas.microsoft.com/office/drawing/2014/main" id="{7452F38C-6B26-414F-A5CF-4B24409711BA}"/>
-              </a:ext>
-            </a:extLst>
-          </p:cNvPr>
-          <p:cNvSpPr>
-            <a:spLocks xmlns:a="http://schemas.openxmlformats.org/drawingml/2006/main" noGrp="1"/>
-          </p:cNvSpPr>
-          <p:nvPr/>
-        </p:nvSpPr>
-        <p:spPr>
-          <a:xfrm xmlns:a="http://schemas.openxmlformats.org/drawingml/2006/main">
-            <a:off x="2038350" y="2667000"/>
-            <a:ext cx="2476500" cy="285750"/>
-          </a:xfrm>
-          <a:prstGeom xmlns:a="http://schemas.openxmlformats.org/drawingml/2006/main" prst="rect">
-            <a:avLst/>
-          </a:prstGeom>
-          <a:noFill xmlns:a="http://schemas.openxmlformats.org/drawingml/2006/main"/>
-          <a:ln xmlns:a="http://schemas.openxmlformats.org/drawingml/2006/main" w="0">
-            <a:noFill/>
-            <a:prstDash val="solid"/>
-          </a:ln>
-        </p:spPr>
-        <p:txBody>
-          <a:bodyPr xmlns:a="http://schemas.openxmlformats.org/drawingml/2006/main"/>
-          <a:lstStyle xmlns:a="http://schemas.openxmlformats.org/drawingml/2006/main"/>
-          <a:p xmlns:a="http://schemas.openxmlformats.org/drawingml/2006/main">
-            <a:pPr algn="l">
-              <a:defRPr sz="1800" b="1">
-                <a:solidFill>
-                  <a:srgbClr val="E6EFEB"/>
-                </a:solidFill>
-              </a:defRPr>
-            </a:pPr>
-            <a:r>
-              <a:rPr sz="1800" b="1">
-                <a:solidFill>
-                  <a:srgbClr val="E6EFEB"/>
-                </a:solidFill>
-              </a:rPr>
-              <a:t>Barge-in</a:t>
-            </a:r>
-          </a:p>
-        </p:txBody>
-      </p:sp>
-      <p:sp>
-        <p:nvSpPr>
-          <p:cNvPr id="9" name="">
-            <a:extLst xmlns:a="http://schemas.openxmlformats.org/drawingml/2006/main">
-              <a:ext uri="{FF2B5EF4-FFF2-40B4-BE49-F238E27FC236}">
-                <a16:creationId xmlns:a16="http://schemas.microsoft.com/office/drawing/2014/main" id="{A098B9E5-D4C8-4A08-BAA0-FFFB7E9C50D6}"/>
-              </a:ext>
-            </a:extLst>
-          </p:cNvPr>
-          <p:cNvSpPr>
-            <a:spLocks xmlns:a="http://schemas.openxmlformats.org/drawingml/2006/main" noGrp="1"/>
-          </p:cNvSpPr>
-          <p:nvPr/>
-        </p:nvSpPr>
-        <p:spPr>
-          <a:xfrm xmlns:a="http://schemas.openxmlformats.org/drawingml/2006/main">
-            <a:off x="2038350" y="3009900"/>
-            <a:ext cx="7429500" cy="228600"/>
-          </a:xfrm>
-          <a:prstGeom xmlns:a="http://schemas.openxmlformats.org/drawingml/2006/main" prst="rect">
-            <a:avLst/>
-          </a:prstGeom>
-          <a:noFill xmlns:a="http://schemas.openxmlformats.org/drawingml/2006/main"/>
-          <a:ln xmlns:a="http://schemas.openxmlformats.org/drawingml/2006/main" w="0">
-            <a:noFill/>
-            <a:prstDash val="solid"/>
-          </a:ln>
-        </p:spPr>
-        <p:txBody>
-          <a:bodyPr xmlns:a="http://schemas.openxmlformats.org/drawingml/2006/main"/>
-          <a:lstStyle xmlns:a="http://schemas.openxmlformats.org/drawingml/2006/main"/>
-          <a:p xmlns:a="http://schemas.openxmlformats.org/drawingml/2006/main">
-            <a:pPr algn="l">
-              <a:defRPr sz="1350" b="0">
-                <a:solidFill>
-                  <a:srgbClr val="8CA098"/>
-                </a:solidFill>
-              </a:defRPr>
-            </a:pPr>
-            <a:r>
-              <a:rPr sz="1350" b="0">
-                <a:solidFill>
-                  <a:srgbClr val="8CA098"/>
-                </a:solidFill>
-              </a:rPr>
-              <a:t>Interrupt mid-answer; show cancellation and truncated spoken history.</a:t>
-            </a:r>
-          </a:p>
-        </p:txBody>
-      </p:sp>
-      <p:sp>
-        <p:nvSpPr>
-          <p:cNvPr id="10" name="">
-            <a:extLst xmlns:a="http://schemas.openxmlformats.org/drawingml/2006/main">
-              <a:ext uri="{FF2B5EF4-FFF2-40B4-BE49-F238E27FC236}">
-                <a16:creationId xmlns:a16="http://schemas.microsoft.com/office/drawing/2014/main" id="{306914E9-D088-4A48-9262-91D77E31BF4E}"/>
-              </a:ext>
-            </a:extLst>
-          </p:cNvPr>
-          <p:cNvSpPr>
-            <a:spLocks xmlns:a="http://schemas.openxmlformats.org/drawingml/2006/main" noGrp="1"/>
-          </p:cNvSpPr>
-          <p:nvPr/>
-        </p:nvSpPr>
-        <p:spPr>
-          <a:xfrm xmlns:a="http://schemas.openxmlformats.org/drawingml/2006/main">
-            <a:off x="990600" y="3524250"/>
-            <a:ext cx="9429750" cy="876300"/>
-          </a:xfrm>
-          <a:prstGeom xmlns:a="http://schemas.openxmlformats.org/drawingml/2006/main" prst="roundRect">
-            <a:avLst>
-              <a:gd name="adj" fmla="val 8696"/>
-            </a:avLst>
-          </a:prstGeom>
-          <a:solidFill xmlns:a="http://schemas.openxmlformats.org/drawingml/2006/main">
-            <a:srgbClr val="111614"/>
-          </a:solidFill>
-          <a:ln xmlns:a="http://schemas.openxmlformats.org/drawingml/2006/main" w="9525">
-            <a:solidFill>
-              <a:srgbClr val="26322F"/>
-            </a:solidFill>
-            <a:prstDash val="solid"/>
-          </a:ln>
-        </p:spPr>
-      </p:sp>
-      <p:sp>
-        <p:nvSpPr>
-          <p:cNvPr id="11" name="">
-            <a:extLst xmlns:a="http://schemas.openxmlformats.org/drawingml/2006/main">
-              <a:ext uri="{FF2B5EF4-FFF2-40B4-BE49-F238E27FC236}">
-                <a16:creationId xmlns:a16="http://schemas.microsoft.com/office/drawing/2014/main" id="{D52408F8-C84A-4760-9B90-4448D72B81B5}"/>
-              </a:ext>
-            </a:extLst>
-          </p:cNvPr>
-          <p:cNvSpPr>
-            <a:spLocks xmlns:a="http://schemas.openxmlformats.org/drawingml/2006/main" noGrp="1"/>
-          </p:cNvSpPr>
-          <p:nvPr/>
-        </p:nvSpPr>
-        <p:spPr>
-          <a:xfrm xmlns:a="http://schemas.openxmlformats.org/drawingml/2006/main">
-            <a:off x="1257300" y="3695700"/>
-            <a:ext cx="476250" cy="438150"/>
-          </a:xfrm>
-          <a:prstGeom xmlns:a="http://schemas.openxmlformats.org/drawingml/2006/main" prst="rect">
-            <a:avLst/>
-          </a:prstGeom>
-          <a:noFill xmlns:a="http://schemas.openxmlformats.org/drawingml/2006/main"/>
-          <a:ln xmlns:a="http://schemas.openxmlformats.org/drawingml/2006/main" w="0">
-            <a:noFill/>
-            <a:prstDash val="solid"/>
-          </a:ln>
-        </p:spPr>
-        <p:txBody>
-          <a:bodyPr xmlns:a="http://schemas.openxmlformats.org/drawingml/2006/main"/>
-          <a:lstStyle xmlns:a="http://schemas.openxmlformats.org/drawingml/2006/main"/>
-          <a:p xmlns:a="http://schemas.openxmlformats.org/drawingml/2006/main">
-            <a:pPr algn="l">
-              <a:defRPr sz="2850" b="1">
-                <a:solidFill>
-                  <a:srgbClr val="34D399"/>
-                </a:solidFill>
-              </a:defRPr>
-            </a:pPr>
-            <a:r>
-              <a:rPr sz="2850" b="1">
-                <a:solidFill>
-                  <a:srgbClr val="34D399"/>
-                </a:solidFill>
-              </a:rPr>
-              <a:t>3</a:t>
-            </a:r>
-          </a:p>
-        </p:txBody>
-      </p:sp>
-      <p:sp>
-        <p:nvSpPr>
-          <p:cNvPr id="12" name="">
-            <a:extLst xmlns:a="http://schemas.openxmlformats.org/drawingml/2006/main">
-              <a:ext uri="{FF2B5EF4-FFF2-40B4-BE49-F238E27FC236}">
-                <a16:creationId xmlns:a16="http://schemas.microsoft.com/office/drawing/2014/main" id="{6068BDAB-4712-47C6-8ADB-FD439B50BB67}"/>
-              </a:ext>
-            </a:extLst>
-          </p:cNvPr>
-          <p:cNvSpPr>
-            <a:spLocks xmlns:a="http://schemas.openxmlformats.org/drawingml/2006/main" noGrp="1"/>
-          </p:cNvSpPr>
-          <p:nvPr/>
-        </p:nvSpPr>
-        <p:spPr>
-          <a:xfrm xmlns:a="http://schemas.openxmlformats.org/drawingml/2006/main">
-            <a:off x="2038350" y="3695700"/>
-            <a:ext cx="2476500" cy="285750"/>
-          </a:xfrm>
-          <a:prstGeom xmlns:a="http://schemas.openxmlformats.org/drawingml/2006/main" prst="rect">
-            <a:avLst/>
-          </a:prstGeom>
-          <a:noFill xmlns:a="http://schemas.openxmlformats.org/drawingml/2006/main"/>
-          <a:ln xmlns:a="http://schemas.openxmlformats.org/drawingml/2006/main" w="0">
-            <a:noFill/>
-            <a:prstDash val="solid"/>
-          </a:ln>
-        </p:spPr>
-        <p:txBody>
-          <a:bodyPr xmlns:a="http://schemas.openxmlformats.org/drawingml/2006/main"/>
-          <a:lstStyle xmlns:a="http://schemas.openxmlformats.org/drawingml/2006/main"/>
-          <a:p xmlns:a="http://schemas.openxmlformats.org/drawingml/2006/main">
-            <a:pPr algn="l">
-              <a:defRPr sz="1800" b="1">
-                <a:solidFill>
-                  <a:srgbClr val="E6EFEB"/>
-                </a:solidFill>
-              </a:defRPr>
-            </a:pPr>
-            <a:r>
-              <a:rPr sz="1800" b="1">
-                <a:solidFill>
-                  <a:srgbClr val="E6EFEB"/>
-                </a:solidFill>
-              </a:rPr>
-              <a:t>Adversarial note</a:t>
-            </a:r>
-          </a:p>
-        </p:txBody>
-      </p:sp>
-      <p:sp>
-        <p:nvSpPr>
-          <p:cNvPr id="13" name="">
-            <a:extLst xmlns:a="http://schemas.openxmlformats.org/drawingml/2006/main">
-              <a:ext uri="{FF2B5EF4-FFF2-40B4-BE49-F238E27FC236}">
-                <a16:creationId xmlns:a16="http://schemas.microsoft.com/office/drawing/2014/main" id="{7F2693AA-B605-476C-80C6-1E298B9DA14B}"/>
-              </a:ext>
-            </a:extLst>
-          </p:cNvPr>
-          <p:cNvSpPr>
-            <a:spLocks xmlns:a="http://schemas.openxmlformats.org/drawingml/2006/main" noGrp="1"/>
-          </p:cNvSpPr>
-          <p:nvPr/>
-        </p:nvSpPr>
-        <p:spPr>
-          <a:xfrm xmlns:a="http://schemas.openxmlformats.org/drawingml/2006/main">
-            <a:off x="2038350" y="4038600"/>
-            <a:ext cx="7429500" cy="228600"/>
-          </a:xfrm>
-          <a:prstGeom xmlns:a="http://schemas.openxmlformats.org/drawingml/2006/main" prst="rect">
-            <a:avLst/>
-          </a:prstGeom>
-          <a:noFill xmlns:a="http://schemas.openxmlformats.org/drawingml/2006/main"/>
-          <a:ln xmlns:a="http://schemas.openxmlformats.org/drawingml/2006/main" w="0">
-            <a:noFill/>
-            <a:prstDash val="solid"/>
-          </a:ln>
-        </p:spPr>
-        <p:txBody>
-          <a:bodyPr xmlns:a="http://schemas.openxmlformats.org/drawingml/2006/main"/>
-          <a:lstStyle xmlns:a="http://schemas.openxmlformats.org/drawingml/2006/main"/>
-          <a:p xmlns:a="http://schemas.openxmlformats.org/drawingml/2006/main">
-            <a:pPr algn="l">
-              <a:defRPr sz="1350" b="0">
-                <a:solidFill>
-                  <a:srgbClr val="8CA098"/>
-                </a:solidFill>
-              </a:defRPr>
-            </a:pPr>
-            <a:r>
-              <a:rPr sz="1350" b="0">
-                <a:solidFill>
-                  <a:srgbClr val="8CA098"/>
-                </a:solidFill>
-              </a:rPr>
-              <a:t>Ask about a poisoned note; show the agent treats it as untrusted text.</a:t>
-            </a:r>
-          </a:p>
-        </p:txBody>
-      </p:sp>
-      <p:sp>
-        <p:nvSpPr>
-          <p:cNvPr id="14" name="">
-            <a:extLst xmlns:a="http://schemas.openxmlformats.org/drawingml/2006/main">
-              <a:ext uri="{FF2B5EF4-FFF2-40B4-BE49-F238E27FC236}">
-                <a16:creationId xmlns:a16="http://schemas.microsoft.com/office/drawing/2014/main" id="{04876F53-E041-4EB9-AFEA-16C7E570F59F}"/>
-              </a:ext>
-            </a:extLst>
-          </p:cNvPr>
-          <p:cNvSpPr>
-            <a:spLocks xmlns:a="http://schemas.openxmlformats.org/drawingml/2006/main" noGrp="1"/>
-          </p:cNvSpPr>
-          <p:nvPr/>
-        </p:nvSpPr>
-        <p:spPr>
-          <a:xfrm xmlns:a="http://schemas.openxmlformats.org/drawingml/2006/main">
-            <a:off x="990600" y="4552950"/>
-            <a:ext cx="9429750" cy="876300"/>
-          </a:xfrm>
-          <a:prstGeom xmlns:a="http://schemas.openxmlformats.org/drawingml/2006/main" prst="roundRect">
-            <a:avLst>
-              <a:gd name="adj" fmla="val 8696"/>
-            </a:avLst>
-          </a:prstGeom>
-          <a:solidFill xmlns:a="http://schemas.openxmlformats.org/drawingml/2006/main">
-            <a:srgbClr val="111614"/>
-          </a:solidFill>
-          <a:ln xmlns:a="http://schemas.openxmlformats.org/drawingml/2006/main" w="9525">
-            <a:solidFill>
-              <a:srgbClr val="26322F"/>
-            </a:solidFill>
-            <a:prstDash val="solid"/>
-          </a:ln>
-        </p:spPr>
-      </p:sp>
-      <p:sp>
-        <p:nvSpPr>
-          <p:cNvPr id="15" name="">
-            <a:extLst xmlns:a="http://schemas.openxmlformats.org/drawingml/2006/main">
-              <a:ext uri="{FF2B5EF4-FFF2-40B4-BE49-F238E27FC236}">
-                <a16:creationId xmlns:a16="http://schemas.microsoft.com/office/drawing/2014/main" id="{ECCE1A61-3089-4433-A7C2-BD34E3B9A4BB}"/>
-              </a:ext>
-            </a:extLst>
-          </p:cNvPr>
-          <p:cNvSpPr>
-            <a:spLocks xmlns:a="http://schemas.openxmlformats.org/drawingml/2006/main" noGrp="1"/>
-          </p:cNvSpPr>
-          <p:nvPr/>
-        </p:nvSpPr>
-        <p:spPr>
-          <a:xfrm xmlns:a="http://schemas.openxmlformats.org/drawingml/2006/main">
-            <a:off x="1257300" y="4724400"/>
-            <a:ext cx="476250" cy="438150"/>
-          </a:xfrm>
-          <a:prstGeom xmlns:a="http://schemas.openxmlformats.org/drawingml/2006/main" prst="rect">
-            <a:avLst/>
-          </a:prstGeom>
-          <a:noFill xmlns:a="http://schemas.openxmlformats.org/drawingml/2006/main"/>
-          <a:ln xmlns:a="http://schemas.openxmlformats.org/drawingml/2006/main" w="0">
-            <a:noFill/>
-            <a:prstDash val="solid"/>
-          </a:ln>
-        </p:spPr>
-        <p:txBody>
-          <a:bodyPr xmlns:a="http://schemas.openxmlformats.org/drawingml/2006/main"/>
-          <a:lstStyle xmlns:a="http://schemas.openxmlformats.org/drawingml/2006/main"/>
-          <a:p xmlns:a="http://schemas.openxmlformats.org/drawingml/2006/main">
-            <a:pPr algn="l">
-              <a:defRPr sz="2850" b="1">
-                <a:solidFill>
-                  <a:srgbClr val="34D399"/>
-                </a:solidFill>
-              </a:defRPr>
-            </a:pPr>
-            <a:r>
-              <a:rPr sz="2850" b="1">
-                <a:solidFill>
-                  <a:srgbClr val="34D399"/>
-                </a:solidFill>
-              </a:rPr>
-              <a:t>4</a:t>
-            </a:r>
-          </a:p>
-        </p:txBody>
-      </p:sp>
-      <p:sp>
-        <p:nvSpPr>
-          <p:cNvPr id="16" name="">
-            <a:extLst xmlns:a="http://schemas.openxmlformats.org/drawingml/2006/main">
-              <a:ext uri="{FF2B5EF4-FFF2-40B4-BE49-F238E27FC236}">
-                <a16:creationId xmlns:a16="http://schemas.microsoft.com/office/drawing/2014/main" id="{FD39BA68-B3A6-4D47-ADBF-AB19F72BBD2C}"/>
-              </a:ext>
-            </a:extLst>
-          </p:cNvPr>
-          <p:cNvSpPr>
-            <a:spLocks xmlns:a="http://schemas.openxmlformats.org/drawingml/2006/main" noGrp="1"/>
-          </p:cNvSpPr>
-          <p:nvPr/>
-        </p:nvSpPr>
-        <p:spPr>
-          <a:xfrm xmlns:a="http://schemas.openxmlformats.org/drawingml/2006/main">
-            <a:off x="2038350" y="4724400"/>
-            <a:ext cx="2476500" cy="285750"/>
-          </a:xfrm>
-          <a:prstGeom xmlns:a="http://schemas.openxmlformats.org/drawingml/2006/main" prst="rect">
-            <a:avLst/>
-          </a:prstGeom>
-          <a:noFill xmlns:a="http://schemas.openxmlformats.org/drawingml/2006/main"/>
-          <a:ln xmlns:a="http://schemas.openxmlformats.org/drawingml/2006/main" w="0">
-            <a:noFill/>
-            <a:prstDash val="solid"/>
-          </a:ln>
-        </p:spPr>
-        <p:txBody>
-          <a:bodyPr xmlns:a="http://schemas.openxmlformats.org/drawingml/2006/main"/>
-          <a:lstStyle xmlns:a="http://schemas.openxmlformats.org/drawingml/2006/main"/>
-          <a:p xmlns:a="http://schemas.openxmlformats.org/drawingml/2006/main">
-            <a:pPr algn="l">
-              <a:defRPr sz="1800" b="1">
-                <a:solidFill>
-                  <a:srgbClr val="E6EFEB"/>
-                </a:solidFill>
-              </a:defRPr>
-            </a:pPr>
-            <a:r>
-              <a:rPr sz="1800" b="1">
-                <a:solidFill>
-                  <a:srgbClr val="E6EFEB"/>
-                </a:solidFill>
-              </a:rPr>
-              <a:t>Eval dashboard</a:t>
-            </a:r>
-          </a:p>
-        </p:txBody>
-      </p:sp>
-      <p:sp>
-        <p:nvSpPr>
-          <p:cNvPr id="17" name="">
-            <a:extLst xmlns:a="http://schemas.openxmlformats.org/drawingml/2006/main">
-              <a:ext uri="{FF2B5EF4-FFF2-40B4-BE49-F238E27FC236}">
-                <a16:creationId xmlns:a16="http://schemas.microsoft.com/office/drawing/2014/main" id="{EDEEC7D2-4781-4DD0-93FA-860CB8D2CFCB}"/>
-              </a:ext>
-            </a:extLst>
-          </p:cNvPr>
-          <p:cNvSpPr>
-            <a:spLocks xmlns:a="http://schemas.openxmlformats.org/drawingml/2006/main" noGrp="1"/>
-          </p:cNvSpPr>
-          <p:nvPr/>
-        </p:nvSpPr>
-        <p:spPr>
-          <a:xfrm xmlns:a="http://schemas.openxmlformats.org/drawingml/2006/main">
-            <a:off x="2038350" y="5067300"/>
-            <a:ext cx="7429500" cy="228600"/>
-          </a:xfrm>
-          <a:prstGeom xmlns:a="http://schemas.openxmlformats.org/drawingml/2006/main" prst="rect">
-            <a:avLst/>
-          </a:prstGeom>
-          <a:noFill xmlns:a="http://schemas.openxmlformats.org/drawingml/2006/main"/>
-          <a:ln xmlns:a="http://schemas.openxmlformats.org/drawingml/2006/main" w="0">
-            <a:noFill/>
-            <a:prstDash val="solid"/>
-          </a:ln>
-        </p:spPr>
-        <p:txBody>
-          <a:bodyPr xmlns:a="http://schemas.openxmlformats.org/drawingml/2006/main"/>
-          <a:lstStyle xmlns:a="http://schemas.openxmlformats.org/drawingml/2006/main"/>
-          <a:p xmlns:a="http://schemas.openxmlformats.org/drawingml/2006/main">
-            <a:pPr algn="l">
-              <a:defRPr sz="1350" b="0">
-                <a:solidFill>
-                  <a:srgbClr val="8CA098"/>
-                </a:solidFill>
-              </a:defRPr>
-            </a:pPr>
-            <a:r>
-              <a:rPr sz="1350" b="0">
-                <a:solidFill>
-                  <a:srgbClr val="8CA098"/>
-                </a:solidFill>
-              </a:rPr>
-              <a:t>Close on recorded eval score, latency, and known remaining failures.</a:t>
-            </a:r>
-          </a:p>
-        </p:txBody>
-      </p:sp>
-      <p:sp>
-        <p:nvSpPr>
-          <p:cNvPr id="18" name="">
-            <a:extLst xmlns:a="http://schemas.openxmlformats.org/drawingml/2006/main">
-              <a:ext uri="{FF2B5EF4-FFF2-40B4-BE49-F238E27FC236}">
-                <a16:creationId xmlns:a16="http://schemas.microsoft.com/office/drawing/2014/main" id="{161BE27B-8337-4B64-8A9B-60DF59DA8074}"/>
-              </a:ext>
-            </a:extLst>
-          </p:cNvPr>
-          <p:cNvSpPr>
-            <a:spLocks xmlns:a="http://schemas.openxmlformats.org/drawingml/2006/main" noGrp="1"/>
-          </p:cNvSpPr>
-          <p:nvPr/>
-        </p:nvSpPr>
-        <p:spPr>
-          <a:xfrm xmlns:a="http://schemas.openxmlformats.org/drawingml/2006/main">
-            <a:off x="685800" y="6324600"/>
-            <a:ext cx="2095500" cy="228600"/>
-          </a:xfrm>
-          <a:prstGeom xmlns:a="http://schemas.openxmlformats.org/drawingml/2006/main" prst="rect">
-            <a:avLst/>
-          </a:prstGeom>
-          <a:noFill xmlns:a="http://schemas.openxmlformats.org/drawingml/2006/main"/>
-          <a:ln xmlns:a="http://schemas.openxmlformats.org/drawingml/2006/main" w="0">
-            <a:noFill/>
-            <a:prstDash val="solid"/>
-          </a:ln>
-        </p:spPr>
-        <p:txBody>
-          <a:bodyPr xmlns:a="http://schemas.openxmlformats.org/drawingml/2006/main"/>
-          <a:lstStyle xmlns:a="http://schemas.openxmlformats.org/drawingml/2006/main"/>
-          <a:p xmlns:a="http://schemas.openxmlformats.org/drawingml/2006/main">
-            <a:pPr algn="l">
-              <a:defRPr sz="1050" b="1">
-                <a:solidFill>
-                  <a:srgbClr val="8CA098"/>
-                </a:solidFill>
-              </a:defRPr>
-            </a:pPr>
-            <a:r>
-              <a:rPr sz="1050" b="1">
-                <a:solidFill>
-                  <a:srgbClr val="8CA098"/>
-                </a:solidFill>
-              </a:rPr>
-              <a:t>voice-agent</a:t>
-            </a:r>
-          </a:p>
-        </p:txBody>
-      </p:sp>
-      <p:sp>
-        <p:nvSpPr>
-          <p:cNvPr id="19" name="">
-            <a:extLst xmlns:a="http://schemas.openxmlformats.org/drawingml/2006/main">
-              <a:ext uri="{FF2B5EF4-FFF2-40B4-BE49-F238E27FC236}">
-                <a16:creationId xmlns:a16="http://schemas.microsoft.com/office/drawing/2014/main" id="{A65A3133-C7B9-46D5-A1C9-4D8E6AB49B03}"/>
-              </a:ext>
-            </a:extLst>
-          </p:cNvPr>
-          <p:cNvSpPr>
-            <a:spLocks xmlns:a="http://schemas.openxmlformats.org/drawingml/2006/main" noGrp="1"/>
-          </p:cNvSpPr>
-          <p:nvPr/>
-        </p:nvSpPr>
-        <p:spPr>
-          <a:xfrm xmlns:a="http://schemas.openxmlformats.org/drawingml/2006/main">
-            <a:off x="10915650" y="6324600"/>
-            <a:ext cx="590550" cy="228600"/>
-          </a:xfrm>
-          <a:prstGeom xmlns:a="http://schemas.openxmlformats.org/drawingml/2006/main" prst="rect">
-            <a:avLst/>
-          </a:prstGeom>
-          <a:noFill xmlns:a="http://schemas.openxmlformats.org/drawingml/2006/main"/>
-          <a:ln xmlns:a="http://schemas.openxmlformats.org/drawingml/2006/main" w="0">
-            <a:noFill/>
-            <a:prstDash val="solid"/>
-          </a:ln>
-        </p:spPr>
-        <p:txBody>
-          <a:bodyPr xmlns:a="http://schemas.openxmlformats.org/drawingml/2006/main"/>
-          <a:lstStyle xmlns:a="http://schemas.openxmlformats.org/drawingml/2006/main"/>
-          <a:p xmlns:a="http://schemas.openxmlformats.org/drawingml/2006/main">
-            <a:pPr algn="r">
-              <a:defRPr sz="1050" b="0">
-                <a:solidFill>
-                  <a:srgbClr val="8CA098"/>
-                </a:solidFill>
-              </a:defRPr>
-            </a:pPr>
-            <a:r>
-              <a:rPr sz="1050" b="0">
-                <a:solidFill>
-                  <a:srgbClr val="8CA098"/>
-                </a:solidFill>
-              </a:rPr>
-              <a:t>09</a:t>
-            </a:r>
-          </a:p>
-        </p:txBody>
-      </p:sp>
-    </p:spTree>
-    <p:extLst>
-      <p:ext uri="{BB962C8B-B14F-4D97-AF65-F5344CB8AC3E}">
-        <p14:creationId xmlns:p14="http://schemas.microsoft.com/office/powerpoint/2010/main" val="1156358083"/>
       </p:ext>
     </p:extLst>
   </p:cSld>

</xml_diff>

<commit_message>
Prepare voice agent for submission
</commit_message>
<xml_diff>
--- a/docs/application/voice-agent-summary-deck.pptx
+++ b/docs/application/voice-agent-summary-deck.pptx
@@ -2,20 +2,20 @@
 <file path=ppt/presentation.xml><?xml version="1.0" encoding="utf-8"?>
 <p:presentation xmlns:p="http://schemas.openxmlformats.org/presentationml/2006/main">
   <p:sldMasterIdLst>
-    <p:sldMasterId xmlns:r="http://schemas.openxmlformats.org/officeDocument/2006/relationships" id="2147483648" r:id="R6141321a0b2a4aa2"/>
+    <p:sldMasterId xmlns:r="http://schemas.openxmlformats.org/officeDocument/2006/relationships" id="2147483648" r:id="Rbb1d974876e44ea8"/>
   </p:sldMasterIdLst>
   <p:notesMasterIdLst>
-    <p:notesMasterId xmlns:r="http://schemas.openxmlformats.org/officeDocument/2006/relationships" r:id="Rd85f4e626f404e1e"/>
+    <p:notesMasterId xmlns:r="http://schemas.openxmlformats.org/officeDocument/2006/relationships" r:id="R5f093b318ba94e03"/>
   </p:notesMasterIdLst>
   <p:sldIdLst>
-    <p:sldId xmlns:r="http://schemas.openxmlformats.org/officeDocument/2006/relationships" id="256" r:id="R9f92796f55d0424b"/>
-    <p:sldId xmlns:r="http://schemas.openxmlformats.org/officeDocument/2006/relationships" id="257" r:id="Reaa9c29aea71493f"/>
-    <p:sldId xmlns:r="http://schemas.openxmlformats.org/officeDocument/2006/relationships" id="258" r:id="Rc583b32841bb4015"/>
-    <p:sldId xmlns:r="http://schemas.openxmlformats.org/officeDocument/2006/relationships" id="259" r:id="Rd4241c624cd24abf"/>
-    <p:sldId xmlns:r="http://schemas.openxmlformats.org/officeDocument/2006/relationships" id="260" r:id="Rdaf7acc8a46d4e6e"/>
-    <p:sldId xmlns:r="http://schemas.openxmlformats.org/officeDocument/2006/relationships" id="261" r:id="Rb970cdfc0f7c48d4"/>
-    <p:sldId xmlns:r="http://schemas.openxmlformats.org/officeDocument/2006/relationships" id="262" r:id="Rbb94438f50f94b2a"/>
-    <p:sldId xmlns:r="http://schemas.openxmlformats.org/officeDocument/2006/relationships" id="263" r:id="Rafb91d132e414a07"/>
+    <p:sldId xmlns:r="http://schemas.openxmlformats.org/officeDocument/2006/relationships" id="256" r:id="Rb9f204cb0bd944fa"/>
+    <p:sldId xmlns:r="http://schemas.openxmlformats.org/officeDocument/2006/relationships" id="257" r:id="Rc8b89cb8be874fb1"/>
+    <p:sldId xmlns:r="http://schemas.openxmlformats.org/officeDocument/2006/relationships" id="258" r:id="R79e642cd6b014ddb"/>
+    <p:sldId xmlns:r="http://schemas.openxmlformats.org/officeDocument/2006/relationships" id="259" r:id="R2603eeb4732f4d3b"/>
+    <p:sldId xmlns:r="http://schemas.openxmlformats.org/officeDocument/2006/relationships" id="260" r:id="R234ae1c62e194fa4"/>
+    <p:sldId xmlns:r="http://schemas.openxmlformats.org/officeDocument/2006/relationships" id="261" r:id="Rbe95fee2ed334523"/>
+    <p:sldId xmlns:r="http://schemas.openxmlformats.org/officeDocument/2006/relationships" id="262" r:id="R37e72ff79b864cfc"/>
+    <p:sldId xmlns:r="http://schemas.openxmlformats.org/officeDocument/2006/relationships" id="263" r:id="R79cfcb64f5244244"/>
   </p:sldIdLst>
   <p:sldSz cx="12192000" cy="6858000"/>
   <p:notesSz cx="6858000" cy="9144000"/>
@@ -975,7 +975,7 @@
   </p:cSld>
   <p:clrMap bg1="lt1" tx1="dk1" bg2="lt2" tx2="dk2" accent1="accent1" accent2="accent2" accent3="accent3" accent4="accent4" accent5="accent5" accent6="accent6" hlink="hlink" folHlink="folHlink"/>
   <p:sldLayoutIdLst>
-    <p:sldLayoutId xmlns:r="http://schemas.openxmlformats.org/officeDocument/2006/relationships" id="2147483649" r:id="R08380b6a0d934c1b"/>
+    <p:sldLayoutId xmlns:r="http://schemas.openxmlformats.org/officeDocument/2006/relationships" id="2147483649" r:id="R47e1cd7ebfa3441f"/>
   </p:sldLayoutIdLst>
   <p:txStyles>
     <p:titleStyle>
@@ -1523,14 +1523,14 @@
       </p:grpSpPr>
       <p:pic>
         <p:nvPicPr>
-          <p:cNvPr id="12" name=""/>
+          <p:cNvPr id="13" name=""/>
           <p:cNvPicPr>
             <a:picLocks xmlns:a="http://schemas.openxmlformats.org/drawingml/2006/main" noChangeAspect="1"/>
           </p:cNvPicPr>
           <p:nvPr/>
         </p:nvPicPr>
         <p:blipFill>
-          <a:blip xmlns:r="http://schemas.openxmlformats.org/officeDocument/2006/relationships" xmlns:a="http://schemas.openxmlformats.org/drawingml/2006/main" r:embed="Rbc1fcddd2da04a47"/>
+          <a:blip xmlns:r="http://schemas.openxmlformats.org/officeDocument/2006/relationships" xmlns:a="http://schemas.openxmlformats.org/drawingml/2006/main" r:embed="R275dcc3516d14bd8"/>
           <a:srcRect xmlns:a="http://schemas.openxmlformats.org/drawingml/2006/main" l="0" t="0" r="0" b="0"/>
           <a:stretch xmlns:a="http://schemas.openxmlformats.org/drawingml/2006/main">
             <a:fillRect l="0" t="0" r="0" b="0"/>
@@ -1615,7 +1615,7 @@
         </p:nvSpPr>
         <p:spPr>
           <a:xfrm xmlns:a="http://schemas.openxmlformats.org/drawingml/2006/main">
-            <a:off x="704850" y="5467350"/>
+            <a:off x="685800" y="5467350"/>
             <a:ext cx="8382000" cy="457200"/>
           </a:xfrm>
           <a:prstGeom xmlns:a="http://schemas.openxmlformats.org/drawingml/2006/main" prst="rect">
@@ -1769,6 +1769,7 @@
           <a:lstStyle xmlns:a="http://schemas.openxmlformats.org/drawingml/2006/main"/>
           <a:p xmlns:a="http://schemas.openxmlformats.org/drawingml/2006/main">
             <a:pPr>
+              <a:buNone/>
               <a:defRPr sz="750">
                 <a:solidFill>
                   <a:srgbClr val="8CA098"/>
@@ -1819,6 +1820,7 @@
           <a:lstStyle xmlns:a="http://schemas.openxmlformats.org/drawingml/2006/main"/>
           <a:p xmlns:a="http://schemas.openxmlformats.org/drawingml/2006/main">
             <a:pPr>
+              <a:buNone/>
               <a:defRPr sz="1050">
                 <a:solidFill>
                   <a:srgbClr val="34D399"/>
@@ -1904,6 +1906,7 @@
           <a:lstStyle xmlns:a="http://schemas.openxmlformats.org/drawingml/2006/main"/>
           <a:p xmlns:a="http://schemas.openxmlformats.org/drawingml/2006/main">
             <a:pPr>
+              <a:buNone/>
               <a:defRPr sz="750">
                 <a:solidFill>
                   <a:srgbClr val="8CA098"/>
@@ -1954,6 +1957,7 @@
           <a:lstStyle xmlns:a="http://schemas.openxmlformats.org/drawingml/2006/main"/>
           <a:p xmlns:a="http://schemas.openxmlformats.org/drawingml/2006/main">
             <a:pPr>
+              <a:buNone/>
               <a:defRPr sz="1050">
                 <a:solidFill>
                   <a:srgbClr val="34D399"/>
@@ -2850,7 +2854,7 @@
           <p:nvPr/>
         </p:nvPicPr>
         <p:blipFill>
-          <a:blip xmlns:r="http://schemas.openxmlformats.org/officeDocument/2006/relationships" xmlns:a="http://schemas.openxmlformats.org/drawingml/2006/main" r:embed="Rc0ae416044a24f52"/>
+          <a:blip xmlns:r="http://schemas.openxmlformats.org/officeDocument/2006/relationships" xmlns:a="http://schemas.openxmlformats.org/drawingml/2006/main" r:embed="R9840fbc3b5164f46"/>
           <a:stretch xmlns:a="http://schemas.openxmlformats.org/drawingml/2006/main"/>
         </p:blipFill>
         <p:spPr>
@@ -3158,7 +3162,7 @@
           <p:nvPr/>
         </p:nvPicPr>
         <p:blipFill>
-          <a:blip xmlns:r="http://schemas.openxmlformats.org/officeDocument/2006/relationships" xmlns:a="http://schemas.openxmlformats.org/drawingml/2006/main" r:embed="R5bcb98c25e49495f"/>
+          <a:blip xmlns:r="http://schemas.openxmlformats.org/officeDocument/2006/relationships" xmlns:a="http://schemas.openxmlformats.org/drawingml/2006/main" r:embed="R1d965b0790c84817"/>
           <a:stretch xmlns:a="http://schemas.openxmlformats.org/drawingml/2006/main"/>
         </p:blipFill>
         <p:spPr>
@@ -5347,7 +5351,7 @@
           <p:nvPr/>
         </p:nvPicPr>
         <p:blipFill>
-          <a:blip xmlns:r="http://schemas.openxmlformats.org/officeDocument/2006/relationships" xmlns:a="http://schemas.openxmlformats.org/drawingml/2006/main" r:embed="Rf152cff4ee6a43aa"/>
+          <a:blip xmlns:r="http://schemas.openxmlformats.org/officeDocument/2006/relationships" xmlns:a="http://schemas.openxmlformats.org/drawingml/2006/main" r:embed="Rea1df9780e9d45fc"/>
           <a:stretch xmlns:a="http://schemas.openxmlformats.org/drawingml/2006/main"/>
         </p:blipFill>
         <p:spPr>
@@ -5993,12 +5997,18 @@
           <p:nvPr/>
         </p:nvPicPr>
         <p:blipFill>
-          <a:blip xmlns:r="http://schemas.openxmlformats.org/officeDocument/2006/relationships" xmlns:a="http://schemas.openxmlformats.org/drawingml/2006/main" r:embed="R89f40af0cb1148ba"/>
+          <a:blip xmlns:r="http://schemas.openxmlformats.org/officeDocument/2006/relationships" xmlns:a="http://schemas.openxmlformats.org/drawingml/2006/main" r:embed="R9b068b0c389b4489">
+            <a:extLst>
+              <a:ext uri="{96DAC541-7B7A-43D3-8B79-37D633B846F1}">
+                <asvg:svgBlip xmlns:asvg="http://schemas.microsoft.com/office/drawing/2016/SVG/main" r:embed="Rbafda0e3d6a44dc5"/>
+              </a:ext>
+            </a:extLst>
+          </a:blip>
           <a:stretch xmlns:a="http://schemas.openxmlformats.org/drawingml/2006/main"/>
         </p:blipFill>
         <p:spPr>
           <a:xfrm xmlns:a="http://schemas.openxmlformats.org/drawingml/2006/main">
-            <a:off x="628650" y="1587341"/>
+            <a:off x="685800" y="1521143"/>
             <a:ext cx="5295900" cy="1721168"/>
           </a:xfrm>
           <a:prstGeom xmlns:a="http://schemas.openxmlformats.org/drawingml/2006/main" prst="roundRect">
@@ -6017,12 +6027,12 @@
           <p:nvPr/>
         </p:nvPicPr>
         <p:blipFill>
-          <a:blip xmlns:r="http://schemas.openxmlformats.org/officeDocument/2006/relationships" xmlns:a="http://schemas.openxmlformats.org/drawingml/2006/main" r:embed="R670fb9b2527d426f"/>
+          <a:blip xmlns:r="http://schemas.openxmlformats.org/officeDocument/2006/relationships" xmlns:a="http://schemas.openxmlformats.org/drawingml/2006/main" r:embed="Rc7d23b30927c47e3"/>
           <a:stretch xmlns:a="http://schemas.openxmlformats.org/drawingml/2006/main"/>
         </p:blipFill>
         <p:spPr>
           <a:xfrm xmlns:a="http://schemas.openxmlformats.org/drawingml/2006/main">
-            <a:off x="6267450" y="1521143"/>
+            <a:off x="6324600" y="1521143"/>
             <a:ext cx="5295900" cy="1853565"/>
           </a:xfrm>
           <a:prstGeom xmlns:a="http://schemas.openxmlformats.org/drawingml/2006/main" prst="roundRect">

</xml_diff>